<commit_message>
fix: scroll isolation per sidebar section (panel-scroll)
</commit_message>
<xml_diff>
--- a/CascadeGuard-Pitch-2min.pptx
+++ b/CascadeGuard-Pitch-2min.pptx
@@ -1,20 +1,20 @@
 
 <file path=ppt/presentation.xml><?xml version="1.0" encoding="utf-8"?>
-<p:presentation xmlns:a="http://schemas.openxmlformats.org/drawingml/2006/main" xmlns:r="http://schemas.openxmlformats.org/officeDocument/2006/relationships" xmlns:p="http://schemas.openxmlformats.org/presentationml/2006/main" saveSubsetFonts="1" autoCompressPictures="0">
+<p:presentation xmlns:a="http://schemas.openxmlformats.org/drawingml/2006/main" xmlns:r="http://schemas.openxmlformats.org/officeDocument/2006/relationships" xmlns:p="http://schemas.openxmlformats.org/presentationml/2006/main" autoCompressPictures="0">
   <p:sldMasterIdLst>
     <p:sldMasterId id="2147483648" r:id="rId1"/>
   </p:sldMasterIdLst>
   <p:sldIdLst>
-    <p:sldId id="256" r:id="rId7"/>
-    <p:sldId id="257" r:id="rId8"/>
-    <p:sldId id="258" r:id="rId9"/>
-    <p:sldId id="259" r:id="rId10"/>
-    <p:sldId id="260" r:id="rId11"/>
-    <p:sldId id="261" r:id="rId12"/>
-    <p:sldId id="262" r:id="rId13"/>
-    <p:sldId id="263" r:id="rId14"/>
+    <p:sldId id="256" r:id="rId3"/>
+    <p:sldId id="257" r:id="rId4"/>
+    <p:sldId id="258" r:id="rId5"/>
+    <p:sldId id="259" r:id="rId6"/>
+    <p:sldId id="260" r:id="rId7"/>
+    <p:sldId id="261" r:id="rId8"/>
+    <p:sldId id="262" r:id="rId9"/>
+    <p:sldId id="263" r:id="rId10"/>
   </p:sldIdLst>
-  <p:sldSz cx="12191695" cy="6858000" type="screen4x3"/>
+  <p:sldSz cx="12191365" cy="6858000" type="screen4x3"/>
   <p:notesSz cx="6858000" cy="9144000"/>
   <p:defaultTextStyle>
     <a:defPPr>
@@ -111,6 +111,22 @@
       </a:defRPr>
     </a:lvl9pPr>
   </p:defaultTextStyle>
+  <p:extLst>
+    <p:ext uri="{EFAFB233-063F-42B5-8137-9DF3F51BA10A}">
+      <p15:sldGuideLst xmlns:p15="http://schemas.microsoft.com/office/powerpoint/2012/main">
+        <p15:guide id="1" orient="horz" pos="2189" userDrawn="1">
+          <p15:clr>
+            <a:srgbClr val="A4A3A4"/>
+          </p15:clr>
+        </p15:guide>
+        <p15:guide id="2" pos="2880" userDrawn="1">
+          <p15:clr>
+            <a:srgbClr val="A4A3A4"/>
+          </p15:clr>
+        </p15:guide>
+      </p15:sldGuideLst>
+    </p:ext>
+  </p:extLst>
 </p:presentation>
 </file>
 
@@ -295,7 +311,6 @@
           <a:p>
             <a:fld id="{5BCAD085-E8A6-8845-BD4E-CB4CCA059FC4}" type="datetimeFigureOut">
               <a:rPr lang="en-US" smtClean="0"/>
-              <a:t>1/27/13</a:t>
             </a:fld>
             <a:endParaRPr lang="en-US"/>
           </a:p>
@@ -337,18 +352,12 @@
           <a:p>
             <a:fld id="{C1FF6DA9-008F-8B48-92A6-B652298478BF}" type="slidenum">
               <a:rPr lang="en-US" smtClean="0"/>
-              <a:t>‹#›</a:t>
             </a:fld>
             <a:endParaRPr lang="en-US"/>
           </a:p>
         </p:txBody>
       </p:sp>
     </p:spTree>
-    <p:extLst>
-      <p:ext uri="{BB962C8B-B14F-4D97-AF65-F5344CB8AC3E}">
-        <p14:creationId xmlns:p14="http://schemas.microsoft.com/office/powerpoint/2010/main" val="3168075583"/>
-      </p:ext>
-    </p:extLst>
   </p:cSld>
   <p:clrMapOvr>
     <a:masterClrMapping/>
@@ -416,6 +425,7 @@
               <a:rPr lang="en-US" smtClean="0"/>
               <a:t>Click to edit Master text styles</a:t>
             </a:r>
+            <a:endParaRPr lang="en-US" smtClean="0"/>
           </a:p>
           <a:p>
             <a:pPr lvl="1"/>
@@ -423,6 +433,7 @@
               <a:rPr lang="en-US" smtClean="0"/>
               <a:t>Second level</a:t>
             </a:r>
+            <a:endParaRPr lang="en-US" smtClean="0"/>
           </a:p>
           <a:p>
             <a:pPr lvl="2"/>
@@ -430,6 +441,7 @@
               <a:rPr lang="en-US" smtClean="0"/>
               <a:t>Third level</a:t>
             </a:r>
+            <a:endParaRPr lang="en-US" smtClean="0"/>
           </a:p>
           <a:p>
             <a:pPr lvl="3"/>
@@ -437,6 +449,7 @@
               <a:rPr lang="en-US" smtClean="0"/>
               <a:t>Fourth level</a:t>
             </a:r>
+            <a:endParaRPr lang="en-US" smtClean="0"/>
           </a:p>
           <a:p>
             <a:pPr lvl="4"/>
@@ -465,7 +478,6 @@
           <a:p>
             <a:fld id="{5BCAD085-E8A6-8845-BD4E-CB4CCA059FC4}" type="datetimeFigureOut">
               <a:rPr lang="en-US" smtClean="0"/>
-              <a:t>1/27/13</a:t>
             </a:fld>
             <a:endParaRPr lang="en-US"/>
           </a:p>
@@ -507,18 +519,12 @@
           <a:p>
             <a:fld id="{C1FF6DA9-008F-8B48-92A6-B652298478BF}" type="slidenum">
               <a:rPr lang="en-US" smtClean="0"/>
-              <a:t>‹#›</a:t>
             </a:fld>
             <a:endParaRPr lang="en-US"/>
           </a:p>
         </p:txBody>
       </p:sp>
     </p:spTree>
-    <p:extLst>
-      <p:ext uri="{BB962C8B-B14F-4D97-AF65-F5344CB8AC3E}">
-        <p14:creationId xmlns:p14="http://schemas.microsoft.com/office/powerpoint/2010/main" val="2910927964"/>
-      </p:ext>
-    </p:extLst>
   </p:cSld>
   <p:clrMapOvr>
     <a:masterClrMapping/>
@@ -596,6 +602,7 @@
               <a:rPr lang="en-US" smtClean="0"/>
               <a:t>Click to edit Master text styles</a:t>
             </a:r>
+            <a:endParaRPr lang="en-US" smtClean="0"/>
           </a:p>
           <a:p>
             <a:pPr lvl="1"/>
@@ -603,6 +610,7 @@
               <a:rPr lang="en-US" smtClean="0"/>
               <a:t>Second level</a:t>
             </a:r>
+            <a:endParaRPr lang="en-US" smtClean="0"/>
           </a:p>
           <a:p>
             <a:pPr lvl="2"/>
@@ -610,6 +618,7 @@
               <a:rPr lang="en-US" smtClean="0"/>
               <a:t>Third level</a:t>
             </a:r>
+            <a:endParaRPr lang="en-US" smtClean="0"/>
           </a:p>
           <a:p>
             <a:pPr lvl="3"/>
@@ -617,6 +626,7 @@
               <a:rPr lang="en-US" smtClean="0"/>
               <a:t>Fourth level</a:t>
             </a:r>
+            <a:endParaRPr lang="en-US" smtClean="0"/>
           </a:p>
           <a:p>
             <a:pPr lvl="4"/>
@@ -645,7 +655,6 @@
           <a:p>
             <a:fld id="{5BCAD085-E8A6-8845-BD4E-CB4CCA059FC4}" type="datetimeFigureOut">
               <a:rPr lang="en-US" smtClean="0"/>
-              <a:t>1/27/13</a:t>
             </a:fld>
             <a:endParaRPr lang="en-US"/>
           </a:p>
@@ -687,18 +696,12 @@
           <a:p>
             <a:fld id="{C1FF6DA9-008F-8B48-92A6-B652298478BF}" type="slidenum">
               <a:rPr lang="en-US" smtClean="0"/>
-              <a:t>‹#›</a:t>
             </a:fld>
             <a:endParaRPr lang="en-US"/>
           </a:p>
         </p:txBody>
       </p:sp>
     </p:spTree>
-    <p:extLst>
-      <p:ext uri="{BB962C8B-B14F-4D97-AF65-F5344CB8AC3E}">
-        <p14:creationId xmlns:p14="http://schemas.microsoft.com/office/powerpoint/2010/main" val="3612223792"/>
-      </p:ext>
-    </p:extLst>
   </p:cSld>
   <p:clrMapOvr>
     <a:masterClrMapping/>
@@ -766,6 +769,7 @@
               <a:rPr lang="en-US" smtClean="0"/>
               <a:t>Click to edit Master text styles</a:t>
             </a:r>
+            <a:endParaRPr lang="en-US" smtClean="0"/>
           </a:p>
           <a:p>
             <a:pPr lvl="1"/>
@@ -773,6 +777,7 @@
               <a:rPr lang="en-US" smtClean="0"/>
               <a:t>Second level</a:t>
             </a:r>
+            <a:endParaRPr lang="en-US" smtClean="0"/>
           </a:p>
           <a:p>
             <a:pPr lvl="2"/>
@@ -780,6 +785,7 @@
               <a:rPr lang="en-US" smtClean="0"/>
               <a:t>Third level</a:t>
             </a:r>
+            <a:endParaRPr lang="en-US" smtClean="0"/>
           </a:p>
           <a:p>
             <a:pPr lvl="3"/>
@@ -787,6 +793,7 @@
               <a:rPr lang="en-US" smtClean="0"/>
               <a:t>Fourth level</a:t>
             </a:r>
+            <a:endParaRPr lang="en-US" smtClean="0"/>
           </a:p>
           <a:p>
             <a:pPr lvl="4"/>
@@ -815,7 +822,6 @@
           <a:p>
             <a:fld id="{5BCAD085-E8A6-8845-BD4E-CB4CCA059FC4}" type="datetimeFigureOut">
               <a:rPr lang="en-US" smtClean="0"/>
-              <a:t>1/27/13</a:t>
             </a:fld>
             <a:endParaRPr lang="en-US"/>
           </a:p>
@@ -857,18 +863,12 @@
           <a:p>
             <a:fld id="{C1FF6DA9-008F-8B48-92A6-B652298478BF}" type="slidenum">
               <a:rPr lang="en-US" smtClean="0"/>
-              <a:t>‹#›</a:t>
             </a:fld>
             <a:endParaRPr lang="en-US"/>
           </a:p>
         </p:txBody>
       </p:sp>
     </p:spTree>
-    <p:extLst>
-      <p:ext uri="{BB962C8B-B14F-4D97-AF65-F5344CB8AC3E}">
-        <p14:creationId xmlns:p14="http://schemas.microsoft.com/office/powerpoint/2010/main" val="2614314258"/>
-      </p:ext>
-    </p:extLst>
   </p:cSld>
   <p:clrMapOvr>
     <a:masterClrMapping/>
@@ -1041,6 +1041,7 @@
               <a:rPr lang="en-US" smtClean="0"/>
               <a:t>Click to edit Master text styles</a:t>
             </a:r>
+            <a:endParaRPr lang="en-US" smtClean="0"/>
           </a:p>
         </p:txBody>
       </p:sp>
@@ -1061,7 +1062,6 @@
           <a:p>
             <a:fld id="{5BCAD085-E8A6-8845-BD4E-CB4CCA059FC4}" type="datetimeFigureOut">
               <a:rPr lang="en-US" smtClean="0"/>
-              <a:t>1/27/13</a:t>
             </a:fld>
             <a:endParaRPr lang="en-US"/>
           </a:p>
@@ -1103,18 +1103,12 @@
           <a:p>
             <a:fld id="{C1FF6DA9-008F-8B48-92A6-B652298478BF}" type="slidenum">
               <a:rPr lang="en-US" smtClean="0"/>
-              <a:t>‹#›</a:t>
             </a:fld>
             <a:endParaRPr lang="en-US"/>
           </a:p>
         </p:txBody>
       </p:sp>
     </p:spTree>
-    <p:extLst>
-      <p:ext uri="{BB962C8B-B14F-4D97-AF65-F5344CB8AC3E}">
-        <p14:creationId xmlns:p14="http://schemas.microsoft.com/office/powerpoint/2010/main" val="960648375"/>
-      </p:ext>
-    </p:extLst>
   </p:cSld>
   <p:clrMapOvr>
     <a:masterClrMapping/>
@@ -1215,6 +1209,7 @@
               <a:rPr lang="en-US" smtClean="0"/>
               <a:t>Click to edit Master text styles</a:t>
             </a:r>
+            <a:endParaRPr lang="en-US" smtClean="0"/>
           </a:p>
           <a:p>
             <a:pPr lvl="1"/>
@@ -1222,6 +1217,7 @@
               <a:rPr lang="en-US" smtClean="0"/>
               <a:t>Second level</a:t>
             </a:r>
+            <a:endParaRPr lang="en-US" smtClean="0"/>
           </a:p>
           <a:p>
             <a:pPr lvl="2"/>
@@ -1229,6 +1225,7 @@
               <a:rPr lang="en-US" smtClean="0"/>
               <a:t>Third level</a:t>
             </a:r>
+            <a:endParaRPr lang="en-US" smtClean="0"/>
           </a:p>
           <a:p>
             <a:pPr lvl="3"/>
@@ -1236,6 +1233,7 @@
               <a:rPr lang="en-US" smtClean="0"/>
               <a:t>Fourth level</a:t>
             </a:r>
+            <a:endParaRPr lang="en-US" smtClean="0"/>
           </a:p>
           <a:p>
             <a:pPr lvl="4"/>
@@ -1300,6 +1298,7 @@
               <a:rPr lang="en-US" smtClean="0"/>
               <a:t>Click to edit Master text styles</a:t>
             </a:r>
+            <a:endParaRPr lang="en-US" smtClean="0"/>
           </a:p>
           <a:p>
             <a:pPr lvl="1"/>
@@ -1307,6 +1306,7 @@
               <a:rPr lang="en-US" smtClean="0"/>
               <a:t>Second level</a:t>
             </a:r>
+            <a:endParaRPr lang="en-US" smtClean="0"/>
           </a:p>
           <a:p>
             <a:pPr lvl="2"/>
@@ -1314,6 +1314,7 @@
               <a:rPr lang="en-US" smtClean="0"/>
               <a:t>Third level</a:t>
             </a:r>
+            <a:endParaRPr lang="en-US" smtClean="0"/>
           </a:p>
           <a:p>
             <a:pPr lvl="3"/>
@@ -1321,6 +1322,7 @@
               <a:rPr lang="en-US" smtClean="0"/>
               <a:t>Fourth level</a:t>
             </a:r>
+            <a:endParaRPr lang="en-US" smtClean="0"/>
           </a:p>
           <a:p>
             <a:pPr lvl="4"/>
@@ -1349,7 +1351,6 @@
           <a:p>
             <a:fld id="{5BCAD085-E8A6-8845-BD4E-CB4CCA059FC4}" type="datetimeFigureOut">
               <a:rPr lang="en-US" smtClean="0"/>
-              <a:t>1/27/13</a:t>
             </a:fld>
             <a:endParaRPr lang="en-US"/>
           </a:p>
@@ -1391,18 +1392,12 @@
           <a:p>
             <a:fld id="{C1FF6DA9-008F-8B48-92A6-B652298478BF}" type="slidenum">
               <a:rPr lang="en-US" smtClean="0"/>
-              <a:t>‹#›</a:t>
             </a:fld>
             <a:endParaRPr lang="en-US"/>
           </a:p>
         </p:txBody>
       </p:sp>
     </p:spTree>
-    <p:extLst>
-      <p:ext uri="{BB962C8B-B14F-4D97-AF65-F5344CB8AC3E}">
-        <p14:creationId xmlns:p14="http://schemas.microsoft.com/office/powerpoint/2010/main" val="2782244947"/>
-      </p:ext>
-    </p:extLst>
   </p:cSld>
   <p:clrMapOvr>
     <a:masterClrMapping/>
@@ -1516,6 +1511,7 @@
               <a:rPr lang="en-US" smtClean="0"/>
               <a:t>Click to edit Master text styles</a:t>
             </a:r>
+            <a:endParaRPr lang="en-US" smtClean="0"/>
           </a:p>
         </p:txBody>
       </p:sp>
@@ -1572,6 +1568,7 @@
               <a:rPr lang="en-US" smtClean="0"/>
               <a:t>Click to edit Master text styles</a:t>
             </a:r>
+            <a:endParaRPr lang="en-US" smtClean="0"/>
           </a:p>
           <a:p>
             <a:pPr lvl="1"/>
@@ -1579,6 +1576,7 @@
               <a:rPr lang="en-US" smtClean="0"/>
               <a:t>Second level</a:t>
             </a:r>
+            <a:endParaRPr lang="en-US" smtClean="0"/>
           </a:p>
           <a:p>
             <a:pPr lvl="2"/>
@@ -1586,6 +1584,7 @@
               <a:rPr lang="en-US" smtClean="0"/>
               <a:t>Third level</a:t>
             </a:r>
+            <a:endParaRPr lang="en-US" smtClean="0"/>
           </a:p>
           <a:p>
             <a:pPr lvl="3"/>
@@ -1593,6 +1592,7 @@
               <a:rPr lang="en-US" smtClean="0"/>
               <a:t>Fourth level</a:t>
             </a:r>
+            <a:endParaRPr lang="en-US" smtClean="0"/>
           </a:p>
           <a:p>
             <a:pPr lvl="4"/>
@@ -1666,6 +1666,7 @@
               <a:rPr lang="en-US" smtClean="0"/>
               <a:t>Click to edit Master text styles</a:t>
             </a:r>
+            <a:endParaRPr lang="en-US" smtClean="0"/>
           </a:p>
         </p:txBody>
       </p:sp>
@@ -1722,6 +1723,7 @@
               <a:rPr lang="en-US" smtClean="0"/>
               <a:t>Click to edit Master text styles</a:t>
             </a:r>
+            <a:endParaRPr lang="en-US" smtClean="0"/>
           </a:p>
           <a:p>
             <a:pPr lvl="1"/>
@@ -1729,6 +1731,7 @@
               <a:rPr lang="en-US" smtClean="0"/>
               <a:t>Second level</a:t>
             </a:r>
+            <a:endParaRPr lang="en-US" smtClean="0"/>
           </a:p>
           <a:p>
             <a:pPr lvl="2"/>
@@ -1736,6 +1739,7 @@
               <a:rPr lang="en-US" smtClean="0"/>
               <a:t>Third level</a:t>
             </a:r>
+            <a:endParaRPr lang="en-US" smtClean="0"/>
           </a:p>
           <a:p>
             <a:pPr lvl="3"/>
@@ -1743,6 +1747,7 @@
               <a:rPr lang="en-US" smtClean="0"/>
               <a:t>Fourth level</a:t>
             </a:r>
+            <a:endParaRPr lang="en-US" smtClean="0"/>
           </a:p>
           <a:p>
             <a:pPr lvl="4"/>
@@ -1771,7 +1776,6 @@
           <a:p>
             <a:fld id="{5BCAD085-E8A6-8845-BD4E-CB4CCA059FC4}" type="datetimeFigureOut">
               <a:rPr lang="en-US" smtClean="0"/>
-              <a:t>1/27/13</a:t>
             </a:fld>
             <a:endParaRPr lang="en-US"/>
           </a:p>
@@ -1813,18 +1817,12 @@
           <a:p>
             <a:fld id="{C1FF6DA9-008F-8B48-92A6-B652298478BF}" type="slidenum">
               <a:rPr lang="en-US" smtClean="0"/>
-              <a:t>‹#›</a:t>
             </a:fld>
             <a:endParaRPr lang="en-US"/>
           </a:p>
         </p:txBody>
       </p:sp>
     </p:spTree>
-    <p:extLst>
-      <p:ext uri="{BB962C8B-B14F-4D97-AF65-F5344CB8AC3E}">
-        <p14:creationId xmlns:p14="http://schemas.microsoft.com/office/powerpoint/2010/main" val="990158736"/>
-      </p:ext>
-    </p:extLst>
   </p:cSld>
   <p:clrMapOvr>
     <a:masterClrMapping/>
@@ -1889,7 +1887,6 @@
           <a:p>
             <a:fld id="{5BCAD085-E8A6-8845-BD4E-CB4CCA059FC4}" type="datetimeFigureOut">
               <a:rPr lang="en-US" smtClean="0"/>
-              <a:t>1/27/13</a:t>
             </a:fld>
             <a:endParaRPr lang="en-US"/>
           </a:p>
@@ -1931,18 +1928,12 @@
           <a:p>
             <a:fld id="{C1FF6DA9-008F-8B48-92A6-B652298478BF}" type="slidenum">
               <a:rPr lang="en-US" smtClean="0"/>
-              <a:t>‹#›</a:t>
             </a:fld>
             <a:endParaRPr lang="en-US"/>
           </a:p>
         </p:txBody>
       </p:sp>
     </p:spTree>
-    <p:extLst>
-      <p:ext uri="{BB962C8B-B14F-4D97-AF65-F5344CB8AC3E}">
-        <p14:creationId xmlns:p14="http://schemas.microsoft.com/office/powerpoint/2010/main" val="727027711"/>
-      </p:ext>
-    </p:extLst>
   </p:cSld>
   <p:clrMapOvr>
     <a:masterClrMapping/>
@@ -1984,7 +1975,6 @@
           <a:p>
             <a:fld id="{5BCAD085-E8A6-8845-BD4E-CB4CCA059FC4}" type="datetimeFigureOut">
               <a:rPr lang="en-US" smtClean="0"/>
-              <a:t>1/27/13</a:t>
             </a:fld>
             <a:endParaRPr lang="en-US"/>
           </a:p>
@@ -2026,18 +2016,12 @@
           <a:p>
             <a:fld id="{C1FF6DA9-008F-8B48-92A6-B652298478BF}" type="slidenum">
               <a:rPr lang="en-US" smtClean="0"/>
-              <a:t>‹#›</a:t>
             </a:fld>
             <a:endParaRPr lang="en-US"/>
           </a:p>
         </p:txBody>
       </p:sp>
     </p:spTree>
-    <p:extLst>
-      <p:ext uri="{BB962C8B-B14F-4D97-AF65-F5344CB8AC3E}">
-        <p14:creationId xmlns:p14="http://schemas.microsoft.com/office/powerpoint/2010/main" val="1212999818"/>
-      </p:ext>
-    </p:extLst>
   </p:cSld>
   <p:clrMapOvr>
     <a:masterClrMapping/>
@@ -2147,6 +2131,7 @@
               <a:rPr lang="en-US" smtClean="0"/>
               <a:t>Click to edit Master text styles</a:t>
             </a:r>
+            <a:endParaRPr lang="en-US" smtClean="0"/>
           </a:p>
           <a:p>
             <a:pPr lvl="1"/>
@@ -2154,6 +2139,7 @@
               <a:rPr lang="en-US" smtClean="0"/>
               <a:t>Second level</a:t>
             </a:r>
+            <a:endParaRPr lang="en-US" smtClean="0"/>
           </a:p>
           <a:p>
             <a:pPr lvl="2"/>
@@ -2161,6 +2147,7 @@
               <a:rPr lang="en-US" smtClean="0"/>
               <a:t>Third level</a:t>
             </a:r>
+            <a:endParaRPr lang="en-US" smtClean="0"/>
           </a:p>
           <a:p>
             <a:pPr lvl="3"/>
@@ -2168,6 +2155,7 @@
               <a:rPr lang="en-US" smtClean="0"/>
               <a:t>Fourth level</a:t>
             </a:r>
+            <a:endParaRPr lang="en-US" smtClean="0"/>
           </a:p>
           <a:p>
             <a:pPr lvl="4"/>
@@ -2241,6 +2229,7 @@
               <a:rPr lang="en-US" smtClean="0"/>
               <a:t>Click to edit Master text styles</a:t>
             </a:r>
+            <a:endParaRPr lang="en-US" smtClean="0"/>
           </a:p>
         </p:txBody>
       </p:sp>
@@ -2261,7 +2250,6 @@
           <a:p>
             <a:fld id="{5BCAD085-E8A6-8845-BD4E-CB4CCA059FC4}" type="datetimeFigureOut">
               <a:rPr lang="en-US" smtClean="0"/>
-              <a:t>1/27/13</a:t>
             </a:fld>
             <a:endParaRPr lang="en-US"/>
           </a:p>
@@ -2303,18 +2291,12 @@
           <a:p>
             <a:fld id="{C1FF6DA9-008F-8B48-92A6-B652298478BF}" type="slidenum">
               <a:rPr lang="en-US" smtClean="0"/>
-              <a:t>‹#›</a:t>
             </a:fld>
             <a:endParaRPr lang="en-US"/>
           </a:p>
         </p:txBody>
       </p:sp>
     </p:spTree>
-    <p:extLst>
-      <p:ext uri="{BB962C8B-B14F-4D97-AF65-F5344CB8AC3E}">
-        <p14:creationId xmlns:p14="http://schemas.microsoft.com/office/powerpoint/2010/main" val="1840726560"/>
-      </p:ext>
-    </p:extLst>
   </p:cSld>
   <p:clrMapOvr>
     <a:masterClrMapping/>
@@ -2494,6 +2476,7 @@
               <a:rPr lang="en-US" smtClean="0"/>
               <a:t>Click to edit Master text styles</a:t>
             </a:r>
+            <a:endParaRPr lang="en-US" smtClean="0"/>
           </a:p>
         </p:txBody>
       </p:sp>
@@ -2514,7 +2497,6 @@
           <a:p>
             <a:fld id="{5BCAD085-E8A6-8845-BD4E-CB4CCA059FC4}" type="datetimeFigureOut">
               <a:rPr lang="en-US" smtClean="0"/>
-              <a:t>1/27/13</a:t>
             </a:fld>
             <a:endParaRPr lang="en-US"/>
           </a:p>
@@ -2556,18 +2538,12 @@
           <a:p>
             <a:fld id="{C1FF6DA9-008F-8B48-92A6-B652298478BF}" type="slidenum">
               <a:rPr lang="en-US" smtClean="0"/>
-              <a:t>‹#›</a:t>
             </a:fld>
             <a:endParaRPr lang="en-US"/>
           </a:p>
         </p:txBody>
       </p:sp>
     </p:spTree>
-    <p:extLst>
-      <p:ext uri="{BB962C8B-B14F-4D97-AF65-F5344CB8AC3E}">
-        <p14:creationId xmlns:p14="http://schemas.microsoft.com/office/powerpoint/2010/main" val="3889236939"/>
-      </p:ext>
-    </p:extLst>
   </p:cSld>
   <p:clrMapOvr>
     <a:masterClrMapping/>
@@ -2660,6 +2636,7 @@
               <a:rPr lang="en-US" smtClean="0"/>
               <a:t>Click to edit Master text styles</a:t>
             </a:r>
+            <a:endParaRPr lang="en-US" smtClean="0"/>
           </a:p>
           <a:p>
             <a:pPr lvl="1"/>
@@ -2667,6 +2644,7 @@
               <a:rPr lang="en-US" smtClean="0"/>
               <a:t>Second level</a:t>
             </a:r>
+            <a:endParaRPr lang="en-US" smtClean="0"/>
           </a:p>
           <a:p>
             <a:pPr lvl="2"/>
@@ -2674,6 +2652,7 @@
               <a:rPr lang="en-US" smtClean="0"/>
               <a:t>Third level</a:t>
             </a:r>
+            <a:endParaRPr lang="en-US" smtClean="0"/>
           </a:p>
           <a:p>
             <a:pPr lvl="3"/>
@@ -2681,6 +2660,7 @@
               <a:rPr lang="en-US" smtClean="0"/>
               <a:t>Fourth level</a:t>
             </a:r>
+            <a:endParaRPr lang="en-US" smtClean="0"/>
           </a:p>
           <a:p>
             <a:pPr lvl="4"/>
@@ -2727,7 +2707,6 @@
           <a:p>
             <a:fld id="{5BCAD085-E8A6-8845-BD4E-CB4CCA059FC4}" type="datetimeFigureOut">
               <a:rPr lang="en-US" smtClean="0"/>
-              <a:t>1/27/13</a:t>
             </a:fld>
             <a:endParaRPr lang="en-US"/>
           </a:p>
@@ -2805,18 +2784,12 @@
           <a:p>
             <a:fld id="{C1FF6DA9-008F-8B48-92A6-B652298478BF}" type="slidenum">
               <a:rPr lang="en-US" smtClean="0"/>
-              <a:t>‹#›</a:t>
             </a:fld>
             <a:endParaRPr lang="en-US"/>
           </a:p>
         </p:txBody>
       </p:sp>
     </p:spTree>
-    <p:extLst>
-      <p:ext uri="{BB962C8B-B14F-4D97-AF65-F5344CB8AC3E}">
-        <p14:creationId xmlns:p14="http://schemas.microsoft.com/office/powerpoint/2010/main" val="2209977519"/>
-      </p:ext>
-    </p:extLst>
   </p:cSld>
   <p:clrMap bg1="lt1" tx1="dk1" bg2="lt2" tx2="dk2" accent1="accent1" accent2="accent2" accent3="accent3" accent4="accent4" accent5="accent5" accent6="accent6" hlink="hlink" folHlink="folHlink"/>
   <p:sldLayoutIdLst>
@@ -2854,7 +2827,7 @@
         <a:spcBef>
           <a:spcPct val="20000"/>
         </a:spcBef>
-        <a:buFont typeface="Arial"/>
+        <a:buFont typeface="Arial" panose="020B0604020202020204"/>
         <a:buChar char="•"/>
         <a:defRPr sz="3200" kern="1200">
           <a:solidFill>
@@ -2869,7 +2842,7 @@
         <a:spcBef>
           <a:spcPct val="20000"/>
         </a:spcBef>
-        <a:buFont typeface="Arial"/>
+        <a:buFont typeface="Arial" panose="020B0604020202020204"/>
         <a:buChar char="–"/>
         <a:defRPr sz="2800" kern="1200">
           <a:solidFill>
@@ -2884,7 +2857,7 @@
         <a:spcBef>
           <a:spcPct val="20000"/>
         </a:spcBef>
-        <a:buFont typeface="Arial"/>
+        <a:buFont typeface="Arial" panose="020B0604020202020204"/>
         <a:buChar char="•"/>
         <a:defRPr sz="2400" kern="1200">
           <a:solidFill>
@@ -2899,7 +2872,7 @@
         <a:spcBef>
           <a:spcPct val="20000"/>
         </a:spcBef>
-        <a:buFont typeface="Arial"/>
+        <a:buFont typeface="Arial" panose="020B0604020202020204"/>
         <a:buChar char="–"/>
         <a:defRPr sz="2000" kern="1200">
           <a:solidFill>
@@ -2914,7 +2887,7 @@
         <a:spcBef>
           <a:spcPct val="20000"/>
         </a:spcBef>
-        <a:buFont typeface="Arial"/>
+        <a:buFont typeface="Arial" panose="020B0604020202020204"/>
         <a:buChar char="»"/>
         <a:defRPr sz="2000" kern="1200">
           <a:solidFill>
@@ -2929,7 +2902,7 @@
         <a:spcBef>
           <a:spcPct val="20000"/>
         </a:spcBef>
-        <a:buFont typeface="Arial"/>
+        <a:buFont typeface="Arial" panose="020B0604020202020204"/>
         <a:buChar char="•"/>
         <a:defRPr sz="2000" kern="1200">
           <a:solidFill>
@@ -2944,7 +2917,7 @@
         <a:spcBef>
           <a:spcPct val="20000"/>
         </a:spcBef>
-        <a:buFont typeface="Arial"/>
+        <a:buFont typeface="Arial" panose="020B0604020202020204"/>
         <a:buChar char="•"/>
         <a:defRPr sz="2000" kern="1200">
           <a:solidFill>
@@ -2959,7 +2932,7 @@
         <a:spcBef>
           <a:spcPct val="20000"/>
         </a:spcBef>
-        <a:buFont typeface="Arial"/>
+        <a:buFont typeface="Arial" panose="020B0604020202020204"/>
         <a:buChar char="•"/>
         <a:defRPr sz="2000" kern="1200">
           <a:solidFill>
@@ -2974,7 +2947,7 @@
         <a:spcBef>
           <a:spcPct val="20000"/>
         </a:spcBef>
-        <a:buFont typeface="Arial"/>
+        <a:buFont typeface="Arial" panose="020B0604020202020204"/>
         <a:buChar char="•"/>
         <a:defRPr sz="2000" kern="1200">
           <a:solidFill>
@@ -3086,7 +3059,7 @@
 </file>
 
 <file path=ppt/slides/slide1.xml><?xml version="1.0" encoding="utf-8"?>
-<p:sld xmlns:a="http://schemas.openxmlformats.org/drawingml/2006/main" xmlns:p="http://schemas.openxmlformats.org/presentationml/2006/main" xmlns:r="http://schemas.openxmlformats.org/officeDocument/2006/relationships">
+<p:sld xmlns:a="http://schemas.openxmlformats.org/drawingml/2006/main" xmlns:r="http://schemas.openxmlformats.org/officeDocument/2006/relationships" xmlns:p="http://schemas.openxmlformats.org/presentationml/2006/main">
   <p:cSld>
     <p:bg>
       <p:bgPr>
@@ -3157,7 +3130,7 @@
         <p:spPr>
           <a:xfrm>
             <a:off x="548640" y="411480"/>
-            <a:ext cx="2194560" cy="292608"/>
+            <a:ext cx="2202815" cy="429260"/>
           </a:xfrm>
           <a:prstGeom prst="roundRect">
             <a:avLst>
@@ -3203,8 +3176,49 @@
         </p:nvSpPr>
         <p:spPr>
           <a:xfrm>
-            <a:off x="685800" y="429768"/>
-            <a:ext cx="1920240" cy="256032"/>
+            <a:off x="685800" y="429895"/>
+            <a:ext cx="2057400" cy="411480"/>
+          </a:xfrm>
+          <a:prstGeom prst="rect">
+            <a:avLst/>
+          </a:prstGeom>
+          <a:noFill/>
+        </p:spPr>
+        <p:txBody>
+          <a:bodyPr wrap="square">
+            <a:noAutofit/>
+          </a:bodyPr>
+          <a:lstStyle/>
+          <a:p>
+            <a:pPr algn="ctr"/>
+            <a:r>
+              <a:rPr sz="900" b="0">
+                <a:solidFill>
+                  <a:srgbClr val="949CAE"/>
+                </a:solidFill>
+                <a:latin typeface="JetBrains Mono"/>
+              </a:rPr>
+              <a:t>ORCATHON 2026  ·  TRACK 01  SOFTWARE &amp; AI</a:t>
+            </a:r>
+            <a:endParaRPr sz="900" b="0">
+              <a:solidFill>
+                <a:srgbClr val="949CAE"/>
+              </a:solidFill>
+              <a:latin typeface="JetBrains Mono"/>
+            </a:endParaRPr>
+          </a:p>
+        </p:txBody>
+      </p:sp>
+      <p:sp>
+        <p:nvSpPr>
+          <p:cNvPr id="5" name="TextBox 4"/>
+          <p:cNvSpPr txBox="1"/>
+          <p:nvPr/>
+        </p:nvSpPr>
+        <p:spPr>
+          <a:xfrm>
+            <a:off x="548640" y="1554480"/>
+            <a:ext cx="10515600" cy="1463040"/>
           </a:xfrm>
           <a:prstGeom prst="rect">
             <a:avLst/>
@@ -3217,29 +3231,35 @@
           </a:bodyPr>
           <a:lstStyle/>
           <a:p>
-            <a:pPr algn="ctr"/>
-            <a:r>
-              <a:rPr sz="900" b="0">
-                <a:solidFill>
-                  <a:srgbClr val="949CAE"/>
-                </a:solidFill>
-                <a:latin typeface="JetBrains Mono"/>
-              </a:rPr>
-              <a:t>ORCATHON 2026  ·  TRACK 01  SOFTWARE &amp; AI</a:t>
-            </a:r>
-          </a:p>
-        </p:txBody>
-      </p:sp>
-      <p:sp>
-        <p:nvSpPr>
-          <p:cNvPr id="5" name="TextBox 4"/>
+            <a:pPr algn="l"/>
+            <a:r>
+              <a:rPr sz="8000" b="1">
+                <a:solidFill>
+                  <a:srgbClr val="F4F6F8"/>
+                </a:solidFill>
+                <a:latin typeface="Inter"/>
+              </a:rPr>
+              <a:t>CascadeGuard</a:t>
+            </a:r>
+            <a:endParaRPr sz="8000" b="1">
+              <a:solidFill>
+                <a:srgbClr val="F4F6F8"/>
+              </a:solidFill>
+              <a:latin typeface="Inter"/>
+            </a:endParaRPr>
+          </a:p>
+        </p:txBody>
+      </p:sp>
+      <p:sp>
+        <p:nvSpPr>
+          <p:cNvPr id="6" name="TextBox 5"/>
           <p:cNvSpPr txBox="1"/>
           <p:nvPr/>
         </p:nvSpPr>
         <p:spPr>
           <a:xfrm>
-            <a:off x="548640" y="1554480"/>
-            <a:ext cx="10515600" cy="1463040"/>
+            <a:off x="548640" y="3200400"/>
+            <a:ext cx="10515600" cy="914400"/>
           </a:xfrm>
           <a:prstGeom prst="rect">
             <a:avLst/>
@@ -3254,49 +3274,20 @@
           <a:p>
             <a:pPr algn="l"/>
             <a:r>
-              <a:rPr sz="8000" b="1">
-                <a:solidFill>
-                  <a:srgbClr val="F4F6F8"/>
+              <a:rPr sz="3200" b="0">
+                <a:solidFill>
+                  <a:srgbClr val="38D0F5"/>
                 </a:solidFill>
                 <a:latin typeface="Inter"/>
               </a:rPr>
-              <a:t>CascadeGuard</a:t>
-            </a:r>
-          </a:p>
-        </p:txBody>
-      </p:sp>
-      <p:sp>
-        <p:nvSpPr>
-          <p:cNvPr id="6" name="TextBox 5"/>
-          <p:cNvSpPr txBox="1"/>
-          <p:nvPr/>
-        </p:nvSpPr>
-        <p:spPr>
-          <a:xfrm>
-            <a:off x="548640" y="3200400"/>
-            <a:ext cx="10515600" cy="914400"/>
-          </a:xfrm>
-          <a:prstGeom prst="rect">
-            <a:avLst/>
-          </a:prstGeom>
-          <a:noFill/>
-        </p:spPr>
-        <p:txBody>
-          <a:bodyPr wrap="square">
-            <a:spAutoFit/>
-          </a:bodyPr>
-          <a:lstStyle/>
-          <a:p>
-            <a:pPr algn="l"/>
-            <a:r>
-              <a:rPr sz="3200" b="0">
-                <a:solidFill>
-                  <a:srgbClr val="38D0F5"/>
-                </a:solidFill>
-                <a:latin typeface="Inter"/>
-              </a:rPr>
               <a:t>See the outage before it happens.</a:t>
             </a:r>
+            <a:endParaRPr sz="3200" b="0">
+              <a:solidFill>
+                <a:srgbClr val="38D0F5"/>
+              </a:solidFill>
+              <a:latin typeface="Inter"/>
+            </a:endParaRPr>
           </a:p>
         </p:txBody>
       </p:sp>
@@ -3375,6 +3366,12 @@
               </a:rPr>
               <a:t>A production-grade AI system that predicts cascading software failures, traces root causes, compares recovery strategies with Monte-Carlo simulation, and verifies predictions live against ground truth — fully in your browser.</a:t>
             </a:r>
+            <a:endParaRPr sz="1400" b="0">
+              <a:solidFill>
+                <a:srgbClr val="949CAE"/>
+              </a:solidFill>
+              <a:latin typeface="Inter"/>
+            </a:endParaRPr>
           </a:p>
         </p:txBody>
       </p:sp>
@@ -3457,6 +3454,12 @@
               </a:rPr>
               <a:t>100%</a:t>
             </a:r>
+            <a:endParaRPr sz="2200" b="1">
+              <a:solidFill>
+                <a:srgbClr val="38D0F5"/>
+              </a:solidFill>
+              <a:latin typeface="Inter"/>
+            </a:endParaRPr>
           </a:p>
         </p:txBody>
       </p:sp>
@@ -3492,6 +3495,12 @@
               </a:rPr>
               <a:t>RECALL  ·  0 MISSED  ·  6 HITS</a:t>
             </a:r>
+            <a:endParaRPr sz="800" b="0">
+              <a:solidFill>
+                <a:srgbClr val="949CAE"/>
+              </a:solidFill>
+              <a:latin typeface="JetBrains Mono"/>
+            </a:endParaRPr>
           </a:p>
         </p:txBody>
       </p:sp>
@@ -3574,6 +3583,12 @@
               </a:rPr>
               <a:t>100%</a:t>
             </a:r>
+            <a:endParaRPr sz="2200" b="1">
+              <a:solidFill>
+                <a:srgbClr val="38D0F5"/>
+              </a:solidFill>
+              <a:latin typeface="Inter"/>
+            </a:endParaRPr>
           </a:p>
         </p:txBody>
       </p:sp>
@@ -3609,6 +3624,12 @@
               </a:rPr>
               <a:t>ORIGIN ACCURACY  ·  4 / 4</a:t>
             </a:r>
+            <a:endParaRPr sz="800" b="0">
+              <a:solidFill>
+                <a:srgbClr val="949CAE"/>
+              </a:solidFill>
+              <a:latin typeface="JetBrains Mono"/>
+            </a:endParaRPr>
           </a:p>
         </p:txBody>
       </p:sp>
@@ -3691,6 +3712,12 @@
               </a:rPr>
               <a:t>75 s</a:t>
             </a:r>
+            <a:endParaRPr sz="2200" b="1">
+              <a:solidFill>
+                <a:srgbClr val="38D0F5"/>
+              </a:solidFill>
+              <a:latin typeface="Inter"/>
+            </a:endParaRPr>
           </a:p>
         </p:txBody>
       </p:sp>
@@ -3726,6 +3753,12 @@
               </a:rPr>
               <a:t>AVG WARNING LEAD  ·  120 s MAX</a:t>
             </a:r>
+            <a:endParaRPr sz="800" b="0">
+              <a:solidFill>
+                <a:srgbClr val="949CAE"/>
+              </a:solidFill>
+              <a:latin typeface="JetBrains Mono"/>
+            </a:endParaRPr>
           </a:p>
         </p:txBody>
       </p:sp>
@@ -3781,7 +3814,7 @@
         <p:spPr>
           <a:xfrm>
             <a:off x="457200" y="6473952"/>
-            <a:ext cx="5943600" cy="274320"/>
+            <a:ext cx="5943600" cy="213995"/>
           </a:xfrm>
           <a:prstGeom prst="rect">
             <a:avLst/>
@@ -3802,8 +3835,32 @@
                 </a:solidFill>
                 <a:latin typeface="JetBrains Mono"/>
               </a:rPr>
-              <a:t>ORCATHON 2026  ·  TRACK 01 SOFTWARE &amp; AI  ·  JAY GHEVARIYA (SOLO)</a:t>
-            </a:r>
+              <a:t>ORCATHON 2026  ·  TRACK 01 SOFTWARE &amp; AI  ·  </a:t>
+            </a:r>
+            <a:r>
+              <a:rPr lang="en-IN" sz="800" b="0">
+                <a:solidFill>
+                  <a:srgbClr val="5A6070"/>
+                </a:solidFill>
+                <a:latin typeface="JetBrains Mono"/>
+              </a:rPr>
+              <a:t>PAL</a:t>
+            </a:r>
+            <a:r>
+              <a:rPr sz="800" b="0">
+                <a:solidFill>
+                  <a:srgbClr val="5A6070"/>
+                </a:solidFill>
+                <a:latin typeface="JetBrains Mono"/>
+              </a:rPr>
+              <a:t> GHEVARIYA (SOLO)</a:t>
+            </a:r>
+            <a:endParaRPr sz="800" b="0">
+              <a:solidFill>
+                <a:srgbClr val="5A6070"/>
+              </a:solidFill>
+              <a:latin typeface="JetBrains Mono"/>
+            </a:endParaRPr>
           </a:p>
         </p:txBody>
       </p:sp>
@@ -3839,6 +3896,12 @@
               </a:rPr>
               <a:t>GITHUB  ·  pal-123456789/cascadeguard  ·  LIVE  ·  cascadeguard-ten.vercel.app</a:t>
             </a:r>
+            <a:endParaRPr sz="800" b="0">
+              <a:solidFill>
+                <a:srgbClr val="7A828F"/>
+              </a:solidFill>
+              <a:latin typeface="JetBrains Mono"/>
+            </a:endParaRPr>
           </a:p>
         </p:txBody>
       </p:sp>
@@ -3851,7 +3914,7 @@
 </file>
 
 <file path=ppt/slides/slide2.xml><?xml version="1.0" encoding="utf-8"?>
-<p:sld xmlns:a="http://schemas.openxmlformats.org/drawingml/2006/main" xmlns:p="http://schemas.openxmlformats.org/presentationml/2006/main" xmlns:r="http://schemas.openxmlformats.org/officeDocument/2006/relationships">
+<p:sld xmlns:a="http://schemas.openxmlformats.org/drawingml/2006/main" xmlns:r="http://schemas.openxmlformats.org/officeDocument/2006/relationships" xmlns:p="http://schemas.openxmlformats.org/presentationml/2006/main">
   <p:cSld>
     <p:bg>
       <p:bgPr>
@@ -3877,7 +3940,7 @@
         <p:spPr>
           <a:xfrm>
             <a:off x="548640" y="365760"/>
-            <a:ext cx="2194560" cy="292608"/>
+            <a:ext cx="2377440" cy="528955"/>
           </a:xfrm>
           <a:prstGeom prst="roundRect">
             <a:avLst>
@@ -3947,6 +4010,12 @@
               </a:rPr>
               <a:t>01  ·  THE PROBLEM  ·  DIGITAL TWIN</a:t>
             </a:r>
+            <a:endParaRPr sz="900" b="0">
+              <a:solidFill>
+                <a:srgbClr val="949CAE"/>
+              </a:solidFill>
+              <a:latin typeface="JetBrains Mono"/>
+            </a:endParaRPr>
           </a:p>
         </p:txBody>
       </p:sp>
@@ -4074,6 +4143,12 @@
               </a:rPr>
               <a:t>GATEWAY</a:t>
             </a:r>
+            <a:endParaRPr sz="900" b="1">
+              <a:solidFill>
+                <a:srgbClr val="060812"/>
+              </a:solidFill>
+              <a:latin typeface="JetBrains Mono"/>
+            </a:endParaRPr>
           </a:p>
         </p:txBody>
       </p:sp>
@@ -4201,6 +4276,12 @@
               </a:rPr>
               <a:t>ORDERS API</a:t>
             </a:r>
+            <a:endParaRPr sz="900" b="1">
+              <a:solidFill>
+                <a:srgbClr val="F4F6F8"/>
+              </a:solidFill>
+              <a:latin typeface="JetBrains Mono"/>
+            </a:endParaRPr>
           </a:p>
         </p:txBody>
       </p:sp>
@@ -4328,6 +4409,12 @@
               </a:rPr>
               <a:t>ORDERS DB  ·  FAILING</a:t>
             </a:r>
+            <a:endParaRPr sz="900" b="1">
+              <a:solidFill>
+                <a:srgbClr val="F4F6F8"/>
+              </a:solidFill>
+              <a:latin typeface="JetBrains Mono"/>
+            </a:endParaRPr>
           </a:p>
         </p:txBody>
       </p:sp>
@@ -4339,7 +4426,7 @@
         </p:nvSpPr>
         <p:spPr>
           <a:xfrm>
-            <a:off x="3474720" y="2743200"/>
+            <a:off x="640080" y="2080260"/>
             <a:ext cx="2468880" cy="502920"/>
           </a:xfrm>
           <a:prstGeom prst="roundRect">
@@ -4386,7 +4473,7 @@
         </p:nvSpPr>
         <p:spPr>
           <a:xfrm>
-            <a:off x="3474720" y="2743200"/>
+            <a:off x="640080" y="2103120"/>
             <a:ext cx="45720" cy="502920"/>
           </a:xfrm>
           <a:prstGeom prst="rect">
@@ -4431,7 +4518,7 @@
         </p:nvSpPr>
         <p:spPr>
           <a:xfrm>
-            <a:off x="3657600" y="2816352"/>
+            <a:off x="822960" y="2194687"/>
             <a:ext cx="2103120" cy="182880"/>
           </a:xfrm>
           <a:prstGeom prst="rect">
@@ -4455,6 +4542,12 @@
               </a:rPr>
               <a:t>INVENTORY API</a:t>
             </a:r>
+            <a:endParaRPr sz="900" b="1">
+              <a:solidFill>
+                <a:srgbClr val="F4F6F8"/>
+              </a:solidFill>
+              <a:latin typeface="JetBrains Mono"/>
+            </a:endParaRPr>
           </a:p>
         </p:txBody>
       </p:sp>
@@ -4582,49 +4675,12 @@
               </a:rPr>
               <a:t>PAYMENTS API</a:t>
             </a:r>
-          </a:p>
-        </p:txBody>
-      </p:sp>
-      <p:sp>
-        <p:nvSpPr>
-          <p:cNvPr id="19" name="Down Arrow 18"/>
-          <p:cNvSpPr/>
-          <p:nvPr/>
-        </p:nvSpPr>
-        <p:spPr>
-          <a:xfrm>
-            <a:off x="2926080" y="4114800"/>
-            <a:ext cx="320040" cy="640080"/>
-          </a:xfrm>
-          <a:prstGeom prst="downArrow">
-            <a:avLst/>
-          </a:prstGeom>
-          <a:solidFill>
-            <a:srgbClr val="F05A6E"/>
-          </a:solidFill>
-          <a:ln>
-            <a:noFill/>
-          </a:ln>
-        </p:spPr>
-        <p:style>
-          <a:lnRef idx="1">
-            <a:schemeClr val="accent1"/>
-          </a:lnRef>
-          <a:fillRef idx="3">
-            <a:schemeClr val="accent1"/>
-          </a:fillRef>
-          <a:effectRef idx="2">
-            <a:schemeClr val="accent1"/>
-          </a:effectRef>
-          <a:fontRef idx="minor">
-            <a:schemeClr val="lt1"/>
-          </a:fontRef>
-        </p:style>
-        <p:txBody>
-          <a:bodyPr rtlCol="0" anchor="ctr"/>
-          <a:lstStyle/>
-          <a:p>
-            <a:pPr algn="ctr"/>
+            <a:endParaRPr sz="900" b="1">
+              <a:solidFill>
+                <a:srgbClr val="F4F6F8"/>
+              </a:solidFill>
+              <a:latin typeface="JetBrains Mono"/>
+            </a:endParaRPr>
           </a:p>
         </p:txBody>
       </p:sp>
@@ -4660,6 +4716,12 @@
               </a:rPr>
               <a:t>A live digital twin of a 9-service e-commerce cluster.</a:t>
             </a:r>
+            <a:endParaRPr sz="2800" b="1">
+              <a:solidFill>
+                <a:srgbClr val="F4F6F8"/>
+              </a:solidFill>
+              <a:latin typeface="Inter"/>
+            </a:endParaRPr>
           </a:p>
         </p:txBody>
       </p:sp>
@@ -4695,6 +4757,12 @@
               </a:rPr>
               <a:t>The gateway feeds APIs; APIs call databases and a cache. When Orders DB's connection pool exhausts, a retry storm amplifies upstream — gateway degradation, orders-api saturation, inventory-api error spike. The cascade isn't a sequence of independent alerts; it's a single failure propagating through a dependency graph. CascadeGuard doesn't watch for symptoms. It predicts the origin.</a:t>
             </a:r>
+            <a:endParaRPr sz="1400" b="0">
+              <a:solidFill>
+                <a:srgbClr val="949CAE"/>
+              </a:solidFill>
+              <a:latin typeface="Inter"/>
+            </a:endParaRPr>
           </a:p>
         </p:txBody>
       </p:sp>
@@ -4777,6 +4845,12 @@
               </a:rPr>
               <a:t>13 dependency edges  ·  9 services  ·  4 fault scenarios  ·  deterministic seed 42</a:t>
             </a:r>
+            <a:endParaRPr sz="1100" b="0">
+              <a:solidFill>
+                <a:srgbClr val="38D0F5"/>
+              </a:solidFill>
+              <a:latin typeface="JetBrains Mono"/>
+            </a:endParaRPr>
           </a:p>
         </p:txBody>
       </p:sp>
@@ -4812,6 +4886,12 @@
               </a:rPr>
               <a:t>Every service, edge weight and capacity is defined in src/core/engine/topology — no synthetic approximation.</a:t>
             </a:r>
+            <a:endParaRPr sz="1000" b="0">
+              <a:solidFill>
+                <a:srgbClr val="949CAE"/>
+              </a:solidFill>
+              <a:latin typeface="Inter"/>
+            </a:endParaRPr>
           </a:p>
         </p:txBody>
       </p:sp>
@@ -4867,7 +4947,7 @@
         <p:spPr>
           <a:xfrm>
             <a:off x="457200" y="6473952"/>
-            <a:ext cx="5943600" cy="274320"/>
+            <a:ext cx="5943600" cy="213995"/>
           </a:xfrm>
           <a:prstGeom prst="rect">
             <a:avLst/>
@@ -4888,8 +4968,32 @@
                 </a:solidFill>
                 <a:latin typeface="JetBrains Mono"/>
               </a:rPr>
-              <a:t>ORCATHON 2026  ·  TRACK 01 SOFTWARE &amp; AI  ·  JAY GHEVARIYA (SOLO)</a:t>
-            </a:r>
+              <a:t>ORCATHON 2026  ·  TRACK 01 SOFTWARE &amp; AI  ·  </a:t>
+            </a:r>
+            <a:r>
+              <a:rPr lang="en-IN" sz="800" b="0">
+                <a:solidFill>
+                  <a:srgbClr val="5A6070"/>
+                </a:solidFill>
+                <a:latin typeface="JetBrains Mono"/>
+              </a:rPr>
+              <a:t>PAL</a:t>
+            </a:r>
+            <a:r>
+              <a:rPr sz="800" b="0">
+                <a:solidFill>
+                  <a:srgbClr val="5A6070"/>
+                </a:solidFill>
+                <a:latin typeface="JetBrains Mono"/>
+              </a:rPr>
+              <a:t> GHEVARIYA (SOLO)</a:t>
+            </a:r>
+            <a:endParaRPr sz="800" b="0">
+              <a:solidFill>
+                <a:srgbClr val="5A6070"/>
+              </a:solidFill>
+              <a:latin typeface="JetBrains Mono"/>
+            </a:endParaRPr>
           </a:p>
         </p:txBody>
       </p:sp>
@@ -4925,6 +5029,12 @@
               </a:rPr>
               <a:t>SCENARIO  ·  CONNECTION POOL EXHAUSTION  ·  LIVE  ·  cascadeguard-ten.vercel.app</a:t>
             </a:r>
+            <a:endParaRPr sz="800" b="0">
+              <a:solidFill>
+                <a:srgbClr val="7A828F"/>
+              </a:solidFill>
+              <a:latin typeface="JetBrains Mono"/>
+            </a:endParaRPr>
           </a:p>
         </p:txBody>
       </p:sp>
@@ -4933,11 +5043,23 @@
   <p:clrMapOvr>
     <a:masterClrMapping/>
   </p:clrMapOvr>
+  <mc:AlternateContent xmlns:mc="http://schemas.openxmlformats.org/markup-compatibility/2006">
+    <mc:Choice xmlns:p15="http://schemas.microsoft.com/office/powerpoint/2012/main" Requires="p15">
+      <p:transition xmlns:p14="http://schemas.microsoft.com/office/powerpoint/2010/main" spd="slow" Requires="p14" p14:dur="1250">
+        <p15:prstTrans prst="airplane"/>
+      </p:transition>
+    </mc:Choice>
+    <mc:Fallback>
+      <p:transition spd="slow">
+        <p:fade/>
+      </p:transition>
+    </mc:Fallback>
+  </mc:AlternateContent>
 </p:sld>
 </file>
 
 <file path=ppt/slides/slide3.xml><?xml version="1.0" encoding="utf-8"?>
-<p:sld xmlns:a="http://schemas.openxmlformats.org/drawingml/2006/main" xmlns:p="http://schemas.openxmlformats.org/presentationml/2006/main" xmlns:r="http://schemas.openxmlformats.org/officeDocument/2006/relationships">
+<p:sld xmlns:a="http://schemas.openxmlformats.org/drawingml/2006/main" xmlns:r="http://schemas.openxmlformats.org/officeDocument/2006/relationships" xmlns:p="http://schemas.openxmlformats.org/presentationml/2006/main">
   <p:cSld>
     <p:bg>
       <p:bgPr>
@@ -4963,7 +5085,7 @@
         <p:spPr>
           <a:xfrm>
             <a:off x="548640" y="365760"/>
-            <a:ext cx="2194560" cy="292608"/>
+            <a:ext cx="2419985" cy="548640"/>
           </a:xfrm>
           <a:prstGeom prst="roundRect">
             <a:avLst>
@@ -5033,6 +5155,12 @@
               </a:rPr>
               <a:t>02  ·  PREDICTION  ·  HYBRID AI  ·  120 s LEAD</a:t>
             </a:r>
+            <a:endParaRPr sz="900" b="0">
+              <a:solidFill>
+                <a:srgbClr val="949CAE"/>
+              </a:solidFill>
+              <a:latin typeface="JetBrains Mono"/>
+            </a:endParaRPr>
           </a:p>
         </p:txBody>
       </p:sp>
@@ -5068,6 +5196,12 @@
               </a:rPr>
               <a:t>120 s</a:t>
             </a:r>
+            <a:endParaRPr sz="12000" b="1">
+              <a:solidFill>
+                <a:srgbClr val="38D0F5"/>
+              </a:solidFill>
+              <a:latin typeface="Inter"/>
+            </a:endParaRPr>
           </a:p>
         </p:txBody>
       </p:sp>
@@ -5103,6 +5237,12 @@
               </a:rPr>
               <a:t>WARNING LEAD TIME  ·  BEFORE ORIGIN SERVICE FAILS  ·  SCENARIO: POOL-EXHAUSTION</a:t>
             </a:r>
+            <a:endParaRPr sz="1100" b="0">
+              <a:solidFill>
+                <a:srgbClr val="949CAE"/>
+              </a:solidFill>
+              <a:latin typeface="JetBrains Mono"/>
+            </a:endParaRPr>
           </a:p>
         </p:txBody>
       </p:sp>
@@ -5183,6 +5323,12 @@
               </a:rPr>
               <a:t>How it predicts</a:t>
             </a:r>
+            <a:endParaRPr sz="2400" b="1">
+              <a:solidFill>
+                <a:srgbClr val="F4F6F8"/>
+              </a:solidFill>
+              <a:latin typeface="Inter"/>
+            </a:endParaRPr>
           </a:p>
         </p:txBody>
       </p:sp>
@@ -5263,6 +5409,12 @@
               </a:rPr>
               <a:t>Logistic risk scorer: 11 weighted signals (memory, saturation, error rate, CPU, p99 latency, EWMA slope trends, log burst).</a:t>
             </a:r>
+            <a:endParaRPr sz="1100" b="0">
+              <a:solidFill>
+                <a:srgbClr val="949CAE"/>
+              </a:solidFill>
+              <a:latin typeface="Inter"/>
+            </a:endParaRPr>
           </a:p>
         </p:txBody>
       </p:sp>
@@ -5343,6 +5495,12 @@
               </a:rPr>
               <a:t>2-hop dependency-graph propagation: risk flows through edges with decay (PROP_GAIN = 0.3).</a:t>
             </a:r>
+            <a:endParaRPr sz="1100" b="0">
+              <a:solidFill>
+                <a:srgbClr val="949CAE"/>
+              </a:solidFill>
+              <a:latin typeface="Inter"/>
+            </a:endParaRPr>
           </a:p>
         </p:txBody>
       </p:sp>
@@ -5423,6 +5581,12 @@
               </a:rPr>
               <a:t>Self-vs-dependency-explained root-cause scoring: origins score higher than victims.</a:t>
             </a:r>
+            <a:endParaRPr sz="1100" b="0">
+              <a:solidFill>
+                <a:srgbClr val="949CAE"/>
+              </a:solidFill>
+              <a:latin typeface="Inter"/>
+            </a:endParaRPr>
           </a:p>
         </p:txBody>
       </p:sp>
@@ -5503,6 +5667,12 @@
               </a:rPr>
               <a:t>Time-based trend window (120 s): speed-invariant at 1×, 2×, 4× or 20× playback.</a:t>
             </a:r>
+            <a:endParaRPr sz="1100" b="0">
+              <a:solidFill>
+                <a:srgbClr val="949CAE"/>
+              </a:solidFill>
+              <a:latin typeface="Inter"/>
+            </a:endParaRPr>
           </a:p>
         </p:txBody>
       </p:sp>
@@ -5583,6 +5753,12 @@
               </a:rPr>
               <a:t>Kind-sensitive risk scaling: database 1.2×, queue 1.15×, gateway 0.95×.</a:t>
             </a:r>
+            <a:endParaRPr sz="1100" b="0">
+              <a:solidFill>
+                <a:srgbClr val="949CAE"/>
+              </a:solidFill>
+              <a:latin typeface="Inter"/>
+            </a:endParaRPr>
           </a:p>
         </p:txBody>
       </p:sp>
@@ -5665,6 +5841,12 @@
               </a:rPr>
               <a:t>120 s</a:t>
             </a:r>
+            <a:endParaRPr sz="2200" b="1">
+              <a:solidFill>
+                <a:srgbClr val="38D0F5"/>
+              </a:solidFill>
+              <a:latin typeface="Inter"/>
+            </a:endParaRPr>
           </a:p>
         </p:txBody>
       </p:sp>
@@ -5700,6 +5882,12 @@
               </a:rPr>
               <a:t>BEST CONFIRMED LEAD</a:t>
             </a:r>
+            <a:endParaRPr sz="900" b="0">
+              <a:solidFill>
+                <a:srgbClr val="949CAE"/>
+              </a:solidFill>
+              <a:latin typeface="JetBrains Mono"/>
+            </a:endParaRPr>
           </a:p>
         </p:txBody>
       </p:sp>
@@ -5782,6 +5970,12 @@
               </a:rPr>
               <a:t>0</a:t>
             </a:r>
+            <a:endParaRPr sz="2200" b="1">
+              <a:solidFill>
+                <a:srgbClr val="38D0F5"/>
+              </a:solidFill>
+              <a:latin typeface="Inter"/>
+            </a:endParaRPr>
           </a:p>
         </p:txBody>
       </p:sp>
@@ -5817,6 +6011,12 @@
               </a:rPr>
               <a:t>MISSED FAILURES</a:t>
             </a:r>
+            <a:endParaRPr sz="900" b="0">
+              <a:solidFill>
+                <a:srgbClr val="949CAE"/>
+              </a:solidFill>
+              <a:latin typeface="JetBrains Mono"/>
+            </a:endParaRPr>
           </a:p>
         </p:txBody>
       </p:sp>
@@ -5899,6 +6099,12 @@
               </a:rPr>
               <a:t>100%</a:t>
             </a:r>
+            <a:endParaRPr sz="2200" b="1">
+              <a:solidFill>
+                <a:srgbClr val="38D0F5"/>
+              </a:solidFill>
+              <a:latin typeface="Inter"/>
+            </a:endParaRPr>
           </a:p>
         </p:txBody>
       </p:sp>
@@ -5934,6 +6140,12 @@
               </a:rPr>
               <a:t>RECALL  ·  6 HITS</a:t>
             </a:r>
+            <a:endParaRPr sz="900" b="0">
+              <a:solidFill>
+                <a:srgbClr val="949CAE"/>
+              </a:solidFill>
+              <a:latin typeface="JetBrains Mono"/>
+            </a:endParaRPr>
           </a:p>
         </p:txBody>
       </p:sp>
@@ -5989,7 +6201,7 @@
         <p:spPr>
           <a:xfrm>
             <a:off x="457200" y="6473952"/>
-            <a:ext cx="5943600" cy="274320"/>
+            <a:ext cx="5943600" cy="213995"/>
           </a:xfrm>
           <a:prstGeom prst="rect">
             <a:avLst/>
@@ -6010,8 +6222,32 @@
                 </a:solidFill>
                 <a:latin typeface="JetBrains Mono"/>
               </a:rPr>
-              <a:t>ORCATHON 2026  ·  TRACK 01 SOFTWARE &amp; AI  ·  JAY GHEVARIYA (SOLO)</a:t>
-            </a:r>
+              <a:t>ORCATHON 2026  ·  TRACK 01 SOFTWARE &amp; AI  ·  </a:t>
+            </a:r>
+            <a:r>
+              <a:rPr lang="en-IN" sz="800" b="0">
+                <a:solidFill>
+                  <a:srgbClr val="5A6070"/>
+                </a:solidFill>
+                <a:latin typeface="JetBrains Mono"/>
+              </a:rPr>
+              <a:t>PAL</a:t>
+            </a:r>
+            <a:r>
+              <a:rPr sz="800" b="0">
+                <a:solidFill>
+                  <a:srgbClr val="5A6070"/>
+                </a:solidFill>
+                <a:latin typeface="JetBrains Mono"/>
+              </a:rPr>
+              <a:t> GHEVARIYA (SOLO)</a:t>
+            </a:r>
+            <a:endParaRPr sz="800" b="0">
+              <a:solidFill>
+                <a:srgbClr val="5A6070"/>
+              </a:solidFill>
+              <a:latin typeface="JetBrains Mono"/>
+            </a:endParaRPr>
           </a:p>
         </p:txBody>
       </p:sp>
@@ -6047,6 +6283,12 @@
               </a:rPr>
               <a:t>VERIFIED  ·  scripts/evaluate.ts  ·  docs/evaluation-report.json  ·  SEED 42  ·  12 SIM-MIN</a:t>
             </a:r>
+            <a:endParaRPr sz="800" b="0">
+              <a:solidFill>
+                <a:srgbClr val="7A828F"/>
+              </a:solidFill>
+              <a:latin typeface="JetBrains Mono"/>
+            </a:endParaRPr>
           </a:p>
         </p:txBody>
       </p:sp>
@@ -6055,11 +6297,23 @@
   <p:clrMapOvr>
     <a:masterClrMapping/>
   </p:clrMapOvr>
+  <mc:AlternateContent xmlns:mc="http://schemas.openxmlformats.org/markup-compatibility/2006">
+    <mc:Choice xmlns:p15="http://schemas.microsoft.com/office/powerpoint/2012/main" Requires="p15">
+      <p:transition xmlns:p14="http://schemas.microsoft.com/office/powerpoint/2010/main" spd="slow" Requires="p14" p14:dur="1250">
+        <p15:prstTrans prst="airplane"/>
+      </p:transition>
+    </mc:Choice>
+    <mc:Fallback>
+      <p:transition spd="slow">
+        <p:fade/>
+      </p:transition>
+    </mc:Fallback>
+  </mc:AlternateContent>
 </p:sld>
 </file>
 
 <file path=ppt/slides/slide4.xml><?xml version="1.0" encoding="utf-8"?>
-<p:sld xmlns:a="http://schemas.openxmlformats.org/drawingml/2006/main" xmlns:p="http://schemas.openxmlformats.org/presentationml/2006/main" xmlns:r="http://schemas.openxmlformats.org/officeDocument/2006/relationships">
+<p:sld xmlns:a="http://schemas.openxmlformats.org/drawingml/2006/main" xmlns:r="http://schemas.openxmlformats.org/officeDocument/2006/relationships" xmlns:p="http://schemas.openxmlformats.org/presentationml/2006/main">
   <p:cSld>
     <p:bg>
       <p:bgPr>
@@ -6085,7 +6339,7 @@
         <p:spPr>
           <a:xfrm>
             <a:off x="548640" y="365760"/>
-            <a:ext cx="2194560" cy="292608"/>
+            <a:ext cx="2577465" cy="718185"/>
           </a:xfrm>
           <a:prstGeom prst="roundRect">
             <a:avLst>
@@ -6155,6 +6409,12 @@
               </a:rPr>
               <a:t>03  ·  ROOT CAUSE  ·  SELF-INFLICTED VS DEPENDENCY-EXPLAINED</a:t>
             </a:r>
+            <a:endParaRPr sz="900" b="0">
+              <a:solidFill>
+                <a:srgbClr val="949CAE"/>
+              </a:solidFill>
+              <a:latin typeface="JetBrains Mono"/>
+            </a:endParaRPr>
           </a:p>
         </p:txBody>
       </p:sp>
@@ -6282,6 +6542,12 @@
               </a:rPr>
               <a:t>Edge Gateway</a:t>
             </a:r>
+            <a:endParaRPr sz="1200" b="1">
+              <a:solidFill>
+                <a:srgbClr val="F4F6F8"/>
+              </a:solidFill>
+              <a:latin typeface="Inter"/>
+            </a:endParaRPr>
           </a:p>
         </p:txBody>
       </p:sp>
@@ -6317,6 +6583,12 @@
               </a:rPr>
               <a:t>SAT: 0.56  ·  ERR: 10%</a:t>
             </a:r>
+            <a:endParaRPr sz="800" b="0">
+              <a:solidFill>
+                <a:srgbClr val="1E6A8C"/>
+              </a:solidFill>
+              <a:latin typeface="JetBrains Mono"/>
+            </a:endParaRPr>
           </a:p>
         </p:txBody>
       </p:sp>
@@ -6487,6 +6759,12 @@
               </a:rPr>
               <a:t>Orders API</a:t>
             </a:r>
+            <a:endParaRPr sz="1200" b="1">
+              <a:solidFill>
+                <a:srgbClr val="F4F6F8"/>
+              </a:solidFill>
+              <a:latin typeface="Inter"/>
+            </a:endParaRPr>
           </a:p>
         </p:txBody>
       </p:sp>
@@ -6522,6 +6800,12 @@
               </a:rPr>
               <a:t>SAT: 0.34  ·  ERR: 48%</a:t>
             </a:r>
+            <a:endParaRPr sz="800" b="0">
+              <a:solidFill>
+                <a:srgbClr val="1E6A8C"/>
+              </a:solidFill>
+              <a:latin typeface="JetBrains Mono"/>
+            </a:endParaRPr>
           </a:p>
         </p:txBody>
       </p:sp>
@@ -6686,12 +6970,18 @@
             <a:r>
               <a:rPr sz="1200" b="1">
                 <a:solidFill>
-                  <a:srgbClr val="060812"/>
+                  <a:schemeClr val="bg1"/>
                 </a:solidFill>
                 <a:latin typeface="Inter"/>
               </a:rPr>
               <a:t>Orders DB  ·  ORIGIN</a:t>
             </a:r>
+            <a:endParaRPr sz="1200" b="1">
+              <a:solidFill>
+                <a:schemeClr val="bg1"/>
+              </a:solidFill>
+              <a:latin typeface="Inter"/>
+            </a:endParaRPr>
           </a:p>
         </p:txBody>
       </p:sp>
@@ -6727,6 +7017,12 @@
               </a:rPr>
               <a:t>SAT: 1.30  ·  ERR: 95%  ·  CONFIDENCE: 95%</a:t>
             </a:r>
+            <a:endParaRPr sz="800" b="0">
+              <a:solidFill>
+                <a:srgbClr val="E8A850"/>
+              </a:solidFill>
+              <a:latin typeface="JetBrains Mono"/>
+            </a:endParaRPr>
           </a:p>
         </p:txBody>
       </p:sp>
@@ -6762,6 +7058,12 @@
               </a:rPr>
               <a:t>The root-cause analyser compares self-inflicted severity (service's own saturation, memory, error rate) against dependency-explained share (how much of its error is explained by unhealthy upstream dependencies). The true origin degrades independently — the victim inherits it.</a:t>
             </a:r>
+            <a:endParaRPr sz="1300" b="0">
+              <a:solidFill>
+                <a:srgbClr val="949CAE"/>
+              </a:solidFill>
+              <a:latin typeface="Inter"/>
+            </a:endParaRPr>
           </a:p>
         </p:txBody>
       </p:sp>
@@ -6844,6 +7146,12 @@
               </a:rPr>
               <a:t>100% ORIGIN ACCURACY  ·  4 / 4 SCENARIOS</a:t>
             </a:r>
+            <a:endParaRPr sz="1800" b="1">
+              <a:solidFill>
+                <a:srgbClr val="38D0F5"/>
+              </a:solidFill>
+              <a:latin typeface="Inter"/>
+            </a:endParaRPr>
           </a:p>
         </p:txBody>
       </p:sp>
@@ -6879,6 +7187,12 @@
               </a:rPr>
               <a:t>Predicted origins: orders-db · payments-api · orders-db · payments-db  ·  All match ground truth exactly.</a:t>
             </a:r>
+            <a:endParaRPr sz="1100" b="0">
+              <a:solidFill>
+                <a:srgbClr val="949CAE"/>
+              </a:solidFill>
+              <a:latin typeface="Inter"/>
+            </a:endParaRPr>
           </a:p>
         </p:txBody>
       </p:sp>
@@ -6934,7 +7248,7 @@
         <p:spPr>
           <a:xfrm>
             <a:off x="457200" y="6473952"/>
-            <a:ext cx="5943600" cy="274320"/>
+            <a:ext cx="5943600" cy="213995"/>
           </a:xfrm>
           <a:prstGeom prst="rect">
             <a:avLst/>
@@ -6955,8 +7269,32 @@
                 </a:solidFill>
                 <a:latin typeface="JetBrains Mono"/>
               </a:rPr>
-              <a:t>ORCATHON 2026  ·  TRACK 01 SOFTWARE &amp; AI  ·  JAY GHEVARIYA (SOLO)</a:t>
-            </a:r>
+              <a:t>ORCATHON 2026  ·  TRACK 01 SOFTWARE &amp; AI  ·  </a:t>
+            </a:r>
+            <a:r>
+              <a:rPr lang="en-IN" sz="800" b="0">
+                <a:solidFill>
+                  <a:srgbClr val="5A6070"/>
+                </a:solidFill>
+                <a:latin typeface="JetBrains Mono"/>
+              </a:rPr>
+              <a:t>PAL</a:t>
+            </a:r>
+            <a:r>
+              <a:rPr sz="800" b="0">
+                <a:solidFill>
+                  <a:srgbClr val="5A6070"/>
+                </a:solidFill>
+                <a:latin typeface="JetBrains Mono"/>
+              </a:rPr>
+              <a:t> GHEVARIYA (SOLO)</a:t>
+            </a:r>
+            <a:endParaRPr sz="800" b="0">
+              <a:solidFill>
+                <a:srgbClr val="5A6070"/>
+              </a:solidFill>
+              <a:latin typeface="JetBrains Mono"/>
+            </a:endParaRPr>
           </a:p>
         </p:txBody>
       </p:sp>
@@ -6992,6 +7330,12 @@
               </a:rPr>
               <a:t>METHOD  ·  BASELINE (10th PERCENTILE)  ·  DEPENDENCY-EXPLAINED SHARE  ·  PATH STRENGTH (DFS ≤ 4 HOPS)</a:t>
             </a:r>
+            <a:endParaRPr sz="800" b="0">
+              <a:solidFill>
+                <a:srgbClr val="7A828F"/>
+              </a:solidFill>
+              <a:latin typeface="JetBrains Mono"/>
+            </a:endParaRPr>
           </a:p>
         </p:txBody>
       </p:sp>
@@ -7000,11 +7344,23 @@
   <p:clrMapOvr>
     <a:masterClrMapping/>
   </p:clrMapOvr>
+  <mc:AlternateContent xmlns:mc="http://schemas.openxmlformats.org/markup-compatibility/2006">
+    <mc:Choice xmlns:p15="http://schemas.microsoft.com/office/powerpoint/2012/main" Requires="p15">
+      <p:transition xmlns:p14="http://schemas.microsoft.com/office/powerpoint/2010/main" spd="slow" Requires="p14" p14:dur="1250">
+        <p15:prstTrans prst="airplane"/>
+      </p:transition>
+    </mc:Choice>
+    <mc:Fallback>
+      <p:transition spd="slow">
+        <p:fade/>
+      </p:transition>
+    </mc:Fallback>
+  </mc:AlternateContent>
 </p:sld>
 </file>
 
 <file path=ppt/slides/slide5.xml><?xml version="1.0" encoding="utf-8"?>
-<p:sld xmlns:a="http://schemas.openxmlformats.org/drawingml/2006/main" xmlns:p="http://schemas.openxmlformats.org/presentationml/2006/main" xmlns:r="http://schemas.openxmlformats.org/officeDocument/2006/relationships">
+<p:sld xmlns:a="http://schemas.openxmlformats.org/drawingml/2006/main" xmlns:r="http://schemas.openxmlformats.org/officeDocument/2006/relationships" xmlns:p="http://schemas.openxmlformats.org/presentationml/2006/main">
   <p:cSld>
     <p:bg>
       <p:bgPr>
@@ -7030,7 +7386,7 @@
         <p:spPr>
           <a:xfrm>
             <a:off x="548640" y="365760"/>
-            <a:ext cx="2194560" cy="292608"/>
+            <a:ext cx="2374265" cy="619125"/>
           </a:xfrm>
           <a:prstGeom prst="roundRect">
             <a:avLst>
@@ -7100,6 +7456,12 @@
               </a:rPr>
               <a:t>04  ·  RECOVERY  ·  MONTE-CARLO OPTIMIZER</a:t>
             </a:r>
+            <a:endParaRPr sz="900" b="0">
+              <a:solidFill>
+                <a:srgbClr val="949CAE"/>
+              </a:solidFill>
+              <a:latin typeface="JetBrains Mono"/>
+            </a:endParaRPr>
           </a:p>
         </p:txBody>
       </p:sp>
@@ -7135,6 +7497,12 @@
               </a:rPr>
               <a:t>Seven strategies · 30 paired rollouts · common random numbers · verdict by baseline comparison</a:t>
             </a:r>
+            <a:endParaRPr sz="2200" b="0">
+              <a:solidFill>
+                <a:srgbClr val="949CAE"/>
+              </a:solidFill>
+              <a:latin typeface="Inter"/>
+            </a:endParaRPr>
           </a:p>
         </p:txBody>
       </p:sp>
@@ -7215,6 +7583,12 @@
               </a:rPr>
               <a:t>STRATEGY</a:t>
             </a:r>
+            <a:endParaRPr sz="800" b="1">
+              <a:solidFill>
+                <a:srgbClr val="38D0F5"/>
+              </a:solidFill>
+              <a:latin typeface="JetBrains Mono"/>
+            </a:endParaRPr>
           </a:p>
         </p:txBody>
       </p:sp>
@@ -7295,6 +7669,12 @@
               </a:rPr>
               <a:t>SUCCESS %</a:t>
             </a:r>
+            <a:endParaRPr sz="800" b="1">
+              <a:solidFill>
+                <a:srgbClr val="38D0F5"/>
+              </a:solidFill>
+              <a:latin typeface="JetBrains Mono"/>
+            </a:endParaRPr>
           </a:p>
         </p:txBody>
       </p:sp>
@@ -7375,6 +7755,12 @@
               </a:rPr>
               <a:t>NEW FAILURES</a:t>
             </a:r>
+            <a:endParaRPr sz="800" b="1">
+              <a:solidFill>
+                <a:srgbClr val="38D0F5"/>
+              </a:solidFill>
+              <a:latin typeface="JetBrains Mono"/>
+            </a:endParaRPr>
           </a:p>
         </p:txBody>
       </p:sp>
@@ -7455,6 +7841,12 @@
               </a:rPr>
               <a:t>DAMAGE</a:t>
             </a:r>
+            <a:endParaRPr sz="800" b="1">
+              <a:solidFill>
+                <a:srgbClr val="38D0F5"/>
+              </a:solidFill>
+              <a:latin typeface="JetBrains Mono"/>
+            </a:endParaRPr>
           </a:p>
         </p:txBody>
       </p:sp>
@@ -7535,6 +7927,12 @@
               </a:rPr>
               <a:t>MTTR</a:t>
             </a:r>
+            <a:endParaRPr sz="800" b="1">
+              <a:solidFill>
+                <a:srgbClr val="38D0F5"/>
+              </a:solidFill>
+              <a:latin typeface="JetBrains Mono"/>
+            </a:endParaRPr>
           </a:p>
         </p:txBody>
       </p:sp>
@@ -7615,6 +8013,12 @@
               </a:rPr>
               <a:t>VERDICT</a:t>
             </a:r>
+            <a:endParaRPr sz="800" b="1">
+              <a:solidFill>
+                <a:srgbClr val="38D0F5"/>
+              </a:solidFill>
+              <a:latin typeface="JetBrains Mono"/>
+            </a:endParaRPr>
           </a:p>
         </p:txBody>
       </p:sp>
@@ -7695,6 +8099,12 @@
               </a:rPr>
               <a:t>failover:orders-db</a:t>
             </a:r>
+            <a:endParaRPr sz="1000" b="1">
+              <a:solidFill>
+                <a:srgbClr val="F4F6F8"/>
+              </a:solidFill>
+              <a:latin typeface="JetBrains Mono"/>
+            </a:endParaRPr>
           </a:p>
         </p:txBody>
       </p:sp>
@@ -7775,6 +8185,12 @@
               </a:rPr>
               <a:t>100%</a:t>
             </a:r>
+            <a:endParaRPr sz="1000" b="1">
+              <a:solidFill>
+                <a:srgbClr val="F4F6F8"/>
+              </a:solidFill>
+              <a:latin typeface="JetBrains Mono"/>
+            </a:endParaRPr>
           </a:p>
         </p:txBody>
       </p:sp>
@@ -7855,6 +8271,12 @@
               </a:rPr>
               <a:t>0.0</a:t>
             </a:r>
+            <a:endParaRPr sz="1000" b="1">
+              <a:solidFill>
+                <a:srgbClr val="F4F6F8"/>
+              </a:solidFill>
+              <a:latin typeface="JetBrains Mono"/>
+            </a:endParaRPr>
           </a:p>
         </p:txBody>
       </p:sp>
@@ -7935,6 +8357,12 @@
               </a:rPr>
               <a:t>0.0</a:t>
             </a:r>
+            <a:endParaRPr sz="1000" b="1">
+              <a:solidFill>
+                <a:srgbClr val="F4F6F8"/>
+              </a:solidFill>
+              <a:latin typeface="JetBrains Mono"/>
+            </a:endParaRPr>
           </a:p>
         </p:txBody>
       </p:sp>
@@ -8015,6 +8443,12 @@
               </a:rPr>
               <a:t>12m</a:t>
             </a:r>
+            <a:endParaRPr sz="1000" b="1">
+              <a:solidFill>
+                <a:srgbClr val="F4F6F8"/>
+              </a:solidFill>
+              <a:latin typeface="JetBrains Mono"/>
+            </a:endParaRPr>
           </a:p>
         </p:txBody>
       </p:sp>
@@ -8140,6 +8574,12 @@
               </a:rPr>
               <a:t>RECOMMENDED</a:t>
             </a:r>
+            <a:endParaRPr sz="1000" b="1">
+              <a:solidFill>
+                <a:srgbClr val="38D0F5"/>
+              </a:solidFill>
+              <a:latin typeface="JetBrains Mono"/>
+            </a:endParaRPr>
           </a:p>
         </p:txBody>
       </p:sp>
@@ -8220,6 +8660,12 @@
               </a:rPr>
               <a:t>circuit-breaker:orders-db</a:t>
             </a:r>
+            <a:endParaRPr sz="1000" b="1">
+              <a:solidFill>
+                <a:srgbClr val="F4F6F8"/>
+              </a:solidFill>
+              <a:latin typeface="JetBrains Mono"/>
+            </a:endParaRPr>
           </a:p>
         </p:txBody>
       </p:sp>
@@ -8300,6 +8746,12 @@
               </a:rPr>
               <a:t>0%</a:t>
             </a:r>
+            <a:endParaRPr sz="1000" b="1">
+              <a:solidFill>
+                <a:srgbClr val="F4F6F8"/>
+              </a:solidFill>
+              <a:latin typeface="JetBrains Mono"/>
+            </a:endParaRPr>
           </a:p>
         </p:txBody>
       </p:sp>
@@ -8380,6 +8832,12 @@
               </a:rPr>
               <a:t>2.6</a:t>
             </a:r>
+            <a:endParaRPr sz="1000" b="1">
+              <a:solidFill>
+                <a:srgbClr val="F4F6F8"/>
+              </a:solidFill>
+              <a:latin typeface="JetBrains Mono"/>
+            </a:endParaRPr>
           </a:p>
         </p:txBody>
       </p:sp>
@@ -8460,6 +8918,12 @@
               </a:rPr>
               <a:t>128.0</a:t>
             </a:r>
+            <a:endParaRPr sz="1000" b="1">
+              <a:solidFill>
+                <a:srgbClr val="F4F6F8"/>
+              </a:solidFill>
+              <a:latin typeface="JetBrains Mono"/>
+            </a:endParaRPr>
           </a:p>
         </p:txBody>
       </p:sp>
@@ -8540,6 +9004,12 @@
               </a:rPr>
               <a:t>12m</a:t>
             </a:r>
+            <a:endParaRPr sz="1000" b="1">
+              <a:solidFill>
+                <a:srgbClr val="F4F6F8"/>
+              </a:solidFill>
+              <a:latin typeface="JetBrains Mono"/>
+            </a:endParaRPr>
           </a:p>
         </p:txBody>
       </p:sp>
@@ -8620,6 +9090,12 @@
               </a:rPr>
               <a:t>NOT RECOMMENDED</a:t>
             </a:r>
+            <a:endParaRPr sz="1000" b="1">
+              <a:solidFill>
+                <a:srgbClr val="F05A6E"/>
+              </a:solidFill>
+              <a:latin typeface="JetBrains Mono"/>
+            </a:endParaRPr>
           </a:p>
         </p:txBody>
       </p:sp>
@@ -8700,6 +9176,12 @@
               </a:rPr>
               <a:t>restart:orders-db</a:t>
             </a:r>
+            <a:endParaRPr sz="1000" b="1">
+              <a:solidFill>
+                <a:srgbClr val="F4F6F8"/>
+              </a:solidFill>
+              <a:latin typeface="JetBrains Mono"/>
+            </a:endParaRPr>
           </a:p>
         </p:txBody>
       </p:sp>
@@ -8780,6 +9262,12 @@
               </a:rPr>
               <a:t>0%</a:t>
             </a:r>
+            <a:endParaRPr sz="1000" b="1">
+              <a:solidFill>
+                <a:srgbClr val="F4F6F8"/>
+              </a:solidFill>
+              <a:latin typeface="JetBrains Mono"/>
+            </a:endParaRPr>
           </a:p>
         </p:txBody>
       </p:sp>
@@ -8860,6 +9348,12 @@
               </a:rPr>
               <a:t>3.0</a:t>
             </a:r>
+            <a:endParaRPr sz="1000" b="1">
+              <a:solidFill>
+                <a:srgbClr val="F4F6F8"/>
+              </a:solidFill>
+              <a:latin typeface="JetBrains Mono"/>
+            </a:endParaRPr>
           </a:p>
         </p:txBody>
       </p:sp>
@@ -8940,6 +9434,12 @@
               </a:rPr>
               <a:t>401.0</a:t>
             </a:r>
+            <a:endParaRPr sz="1000" b="1">
+              <a:solidFill>
+                <a:srgbClr val="F4F6F8"/>
+              </a:solidFill>
+              <a:latin typeface="JetBrains Mono"/>
+            </a:endParaRPr>
           </a:p>
         </p:txBody>
       </p:sp>
@@ -9020,6 +9520,12 @@
               </a:rPr>
               <a:t>12m</a:t>
             </a:r>
+            <a:endParaRPr sz="1000" b="1">
+              <a:solidFill>
+                <a:srgbClr val="F4F6F8"/>
+              </a:solidFill>
+              <a:latin typeface="JetBrains Mono"/>
+            </a:endParaRPr>
           </a:p>
         </p:txBody>
       </p:sp>
@@ -9100,6 +9606,12 @@
               </a:rPr>
               <a:t>NOT RECOMMENDED</a:t>
             </a:r>
+            <a:endParaRPr sz="1000" b="1">
+              <a:solidFill>
+                <a:srgbClr val="F05A6E"/>
+              </a:solidFill>
+              <a:latin typeface="JetBrains Mono"/>
+            </a:endParaRPr>
           </a:p>
         </p:txBody>
       </p:sp>
@@ -9180,6 +9692,12 @@
               </a:rPr>
               <a:t>shed-load:gateway</a:t>
             </a:r>
+            <a:endParaRPr sz="1000" b="1">
+              <a:solidFill>
+                <a:srgbClr val="F4F6F8"/>
+              </a:solidFill>
+              <a:latin typeface="JetBrains Mono"/>
+            </a:endParaRPr>
           </a:p>
         </p:txBody>
       </p:sp>
@@ -9260,6 +9778,12 @@
               </a:rPr>
               <a:t>0%</a:t>
             </a:r>
+            <a:endParaRPr sz="1000" b="1">
+              <a:solidFill>
+                <a:srgbClr val="F4F6F8"/>
+              </a:solidFill>
+              <a:latin typeface="JetBrains Mono"/>
+            </a:endParaRPr>
           </a:p>
         </p:txBody>
       </p:sp>
@@ -9340,6 +9864,12 @@
               </a:rPr>
               <a:t>3.6</a:t>
             </a:r>
+            <a:endParaRPr sz="1000" b="1">
+              <a:solidFill>
+                <a:srgbClr val="F4F6F8"/>
+              </a:solidFill>
+              <a:latin typeface="JetBrains Mono"/>
+            </a:endParaRPr>
           </a:p>
         </p:txBody>
       </p:sp>
@@ -9420,6 +9950,12 @@
               </a:rPr>
               <a:t>158.0</a:t>
             </a:r>
+            <a:endParaRPr sz="1000" b="1">
+              <a:solidFill>
+                <a:srgbClr val="F4F6F8"/>
+              </a:solidFill>
+              <a:latin typeface="JetBrains Mono"/>
+            </a:endParaRPr>
           </a:p>
         </p:txBody>
       </p:sp>
@@ -9500,6 +10036,12 @@
               </a:rPr>
               <a:t>12m</a:t>
             </a:r>
+            <a:endParaRPr sz="1000" b="1">
+              <a:solidFill>
+                <a:srgbClr val="F4F6F8"/>
+              </a:solidFill>
+              <a:latin typeface="JetBrains Mono"/>
+            </a:endParaRPr>
           </a:p>
         </p:txBody>
       </p:sp>
@@ -9580,6 +10122,12 @@
               </a:rPr>
               <a:t>NOT RECOMMENDED</a:t>
             </a:r>
+            <a:endParaRPr sz="1000" b="1">
+              <a:solidFill>
+                <a:srgbClr val="F05A6E"/>
+              </a:solidFill>
+              <a:latin typeface="JetBrains Mono"/>
+            </a:endParaRPr>
           </a:p>
         </p:txBody>
       </p:sp>
@@ -9660,6 +10208,12 @@
               </a:rPr>
               <a:t>no-action</a:t>
             </a:r>
+            <a:endParaRPr sz="1000" b="1">
+              <a:solidFill>
+                <a:srgbClr val="F4F6F8"/>
+              </a:solidFill>
+              <a:latin typeface="JetBrains Mono"/>
+            </a:endParaRPr>
           </a:p>
         </p:txBody>
       </p:sp>
@@ -9740,6 +10294,12 @@
               </a:rPr>
               <a:t>0%</a:t>
             </a:r>
+            <a:endParaRPr sz="1000" b="1">
+              <a:solidFill>
+                <a:srgbClr val="F4F6F8"/>
+              </a:solidFill>
+              <a:latin typeface="JetBrains Mono"/>
+            </a:endParaRPr>
           </a:p>
         </p:txBody>
       </p:sp>
@@ -9820,6 +10380,12 @@
               </a:rPr>
               <a:t>3.5</a:t>
             </a:r>
+            <a:endParaRPr sz="1000" b="1">
+              <a:solidFill>
+                <a:srgbClr val="F4F6F8"/>
+              </a:solidFill>
+              <a:latin typeface="JetBrains Mono"/>
+            </a:endParaRPr>
           </a:p>
         </p:txBody>
       </p:sp>
@@ -9900,6 +10466,12 @@
               </a:rPr>
               <a:t>155.0</a:t>
             </a:r>
+            <a:endParaRPr sz="1000" b="1">
+              <a:solidFill>
+                <a:srgbClr val="F4F6F8"/>
+              </a:solidFill>
+              <a:latin typeface="JetBrains Mono"/>
+            </a:endParaRPr>
           </a:p>
         </p:txBody>
       </p:sp>
@@ -9980,6 +10552,12 @@
               </a:rPr>
               <a:t>12m</a:t>
             </a:r>
+            <a:endParaRPr sz="1000" b="1">
+              <a:solidFill>
+                <a:srgbClr val="F4F6F8"/>
+              </a:solidFill>
+              <a:latin typeface="JetBrains Mono"/>
+            </a:endParaRPr>
           </a:p>
         </p:txBody>
       </p:sp>
@@ -10060,6 +10638,12 @@
               </a:rPr>
               <a:t>NOT RECOMMENDED</a:t>
             </a:r>
+            <a:endParaRPr sz="1000" b="1">
+              <a:solidFill>
+                <a:srgbClr val="F05A6E"/>
+              </a:solidFill>
+              <a:latin typeface="JetBrains Mono"/>
+            </a:endParaRPr>
           </a:p>
         </p:txBody>
       </p:sp>
@@ -10095,6 +10679,12 @@
               </a:rPr>
               <a:t>Paired common-random-number rollouts mean the measured lift (recommended vs not-recommended) is attributable to the action — not random noise. A strategy is 'recommended' only if it beats the no-action baseline (success ≥ 50% + positive lift).</a:t>
             </a:r>
+            <a:endParaRPr sz="1100" b="0">
+              <a:solidFill>
+                <a:srgbClr val="949CAE"/>
+              </a:solidFill>
+              <a:latin typeface="Inter"/>
+            </a:endParaRPr>
           </a:p>
         </p:txBody>
       </p:sp>
@@ -10130,6 +10720,12 @@
               </a:rPr>
               <a:t>ABSTRACT MODEL  ·  DEMAND FLOWS TOPOLOGICALLY  ·  SPILLOVER + RETRY PRESSURE  ·  144 STEPS (12 MIN)  ·  5 s / STEP</a:t>
             </a:r>
+            <a:endParaRPr sz="800" b="0">
+              <a:solidFill>
+                <a:srgbClr val="5A6070"/>
+              </a:solidFill>
+              <a:latin typeface="JetBrains Mono"/>
+            </a:endParaRPr>
           </a:p>
         </p:txBody>
       </p:sp>
@@ -10185,7 +10781,7 @@
         <p:spPr>
           <a:xfrm>
             <a:off x="457200" y="6473952"/>
-            <a:ext cx="5943600" cy="274320"/>
+            <a:ext cx="5943600" cy="213995"/>
           </a:xfrm>
           <a:prstGeom prst="rect">
             <a:avLst/>
@@ -10206,8 +10802,32 @@
                 </a:solidFill>
                 <a:latin typeface="JetBrains Mono"/>
               </a:rPr>
-              <a:t>ORCATHON 2026  ·  TRACK 01 SOFTWARE &amp; AI  ·  JAY GHEVARIYA (SOLO)</a:t>
-            </a:r>
+              <a:t>ORCATHON 2026  ·  TRACK 01 SOFTWARE &amp; AI  ·  </a:t>
+            </a:r>
+            <a:r>
+              <a:rPr lang="en-IN" sz="800" b="0">
+                <a:solidFill>
+                  <a:srgbClr val="5A6070"/>
+                </a:solidFill>
+                <a:latin typeface="JetBrains Mono"/>
+              </a:rPr>
+              <a:t>PAL</a:t>
+            </a:r>
+            <a:r>
+              <a:rPr sz="800" b="0">
+                <a:solidFill>
+                  <a:srgbClr val="5A6070"/>
+                </a:solidFill>
+                <a:latin typeface="JetBrains Mono"/>
+              </a:rPr>
+              <a:t> GHEVARIYA (SOLO)</a:t>
+            </a:r>
+            <a:endParaRPr sz="800" b="0">
+              <a:solidFill>
+                <a:srgbClr val="5A6070"/>
+              </a:solidFill>
+              <a:latin typeface="JetBrains Mono"/>
+            </a:endParaRPr>
           </a:p>
         </p:txBody>
       </p:sp>
@@ -10243,6 +10863,12 @@
               </a:rPr>
               <a:t>SCENARIO  ·  POOL-EXHAUSTION  ·  30 ROLLOUTS  ·  SEED 42  ·  PAID BASELINE SHARED ACROSS ALL STRATEGIES</a:t>
             </a:r>
+            <a:endParaRPr sz="800" b="0">
+              <a:solidFill>
+                <a:srgbClr val="7A828F"/>
+              </a:solidFill>
+              <a:latin typeface="JetBrains Mono"/>
+            </a:endParaRPr>
           </a:p>
         </p:txBody>
       </p:sp>
@@ -10251,11 +10877,23 @@
   <p:clrMapOvr>
     <a:masterClrMapping/>
   </p:clrMapOvr>
+  <mc:AlternateContent xmlns:mc="http://schemas.openxmlformats.org/markup-compatibility/2006">
+    <mc:Choice xmlns:p15="http://schemas.microsoft.com/office/powerpoint/2012/main" Requires="p15">
+      <p:transition xmlns:p14="http://schemas.microsoft.com/office/powerpoint/2010/main" spd="slow" Requires="p14" p14:dur="1250">
+        <p15:prstTrans prst="airplane"/>
+      </p:transition>
+    </mc:Choice>
+    <mc:Fallback>
+      <p:transition spd="slow">
+        <p:fade/>
+      </p:transition>
+    </mc:Fallback>
+  </mc:AlternateContent>
 </p:sld>
 </file>
 
 <file path=ppt/slides/slide6.xml><?xml version="1.0" encoding="utf-8"?>
-<p:sld xmlns:a="http://schemas.openxmlformats.org/drawingml/2006/main" xmlns:p="http://schemas.openxmlformats.org/presentationml/2006/main" xmlns:r="http://schemas.openxmlformats.org/officeDocument/2006/relationships">
+<p:sld xmlns:a="http://schemas.openxmlformats.org/drawingml/2006/main" xmlns:r="http://schemas.openxmlformats.org/officeDocument/2006/relationships" xmlns:p="http://schemas.openxmlformats.org/presentationml/2006/main">
   <p:cSld>
     <p:bg>
       <p:bgPr>
@@ -10281,7 +10919,7 @@
         <p:spPr>
           <a:xfrm>
             <a:off x="548640" y="365760"/>
-            <a:ext cx="2194560" cy="292608"/>
+            <a:ext cx="2284095" cy="652780"/>
           </a:xfrm>
           <a:prstGeom prst="roundRect">
             <a:avLst>
@@ -10351,6 +10989,12 @@
               </a:rPr>
               <a:t>05  ·  BUSINESS IMPACT  ·  SLO METRICS  ·  NOT SERVICE NAMES</a:t>
             </a:r>
+            <a:endParaRPr sz="900" b="0">
+              <a:solidFill>
+                <a:srgbClr val="949CAE"/>
+              </a:solidFill>
+              <a:latin typeface="JetBrains Mono"/>
+            </a:endParaRPr>
           </a:p>
         </p:txBody>
       </p:sp>
@@ -10386,6 +11030,12 @@
               </a:rPr>
               <a:t>What a CTO asks about — converted live from telemetry into business language</a:t>
             </a:r>
+            <a:endParaRPr sz="2400" b="0">
+              <a:solidFill>
+                <a:srgbClr val="F4F6F8"/>
+              </a:solidFill>
+              <a:latin typeface="Inter"/>
+            </a:endParaRPr>
           </a:p>
         </p:txBody>
       </p:sp>
@@ -10513,6 +11163,12 @@
               </a:rPr>
               <a:t>SLO BURN RATE</a:t>
             </a:r>
+            <a:endParaRPr sz="1000" b="0">
+              <a:solidFill>
+                <a:srgbClr val="38D0F5"/>
+              </a:solidFill>
+              <a:latin typeface="JetBrains Mono"/>
+            </a:endParaRPr>
           </a:p>
         </p:txBody>
       </p:sp>
@@ -10548,6 +11204,12 @@
               </a:rPr>
               <a:t>11.37×</a:t>
             </a:r>
+            <a:endParaRPr sz="3600" b="1">
+              <a:solidFill>
+                <a:srgbClr val="38D0F5"/>
+              </a:solidFill>
+              <a:latin typeface="Inter"/>
+            </a:endParaRPr>
           </a:p>
         </p:txBody>
       </p:sp>
@@ -10583,6 +11245,12 @@
               </a:rPr>
               <a:t>Critical threshold exceeded rapidly. Budget depletion accelerates as unhealthy services accumulate.</a:t>
             </a:r>
+            <a:endParaRPr sz="1100" b="0">
+              <a:solidFill>
+                <a:srgbClr val="949CAE"/>
+              </a:solidFill>
+              <a:latin typeface="Inter"/>
+            </a:endParaRPr>
           </a:p>
         </p:txBody>
       </p:sp>
@@ -10618,6 +11286,12 @@
               </a:rPr>
               <a:t>DERIVED FROM SLO THRESHOLD COMPARISON</a:t>
             </a:r>
+            <a:endParaRPr sz="800" b="0">
+              <a:solidFill>
+                <a:srgbClr val="5A6070"/>
+              </a:solidFill>
+              <a:latin typeface="JetBrains Mono"/>
+            </a:endParaRPr>
           </a:p>
         </p:txBody>
       </p:sp>
@@ -10745,6 +11419,12 @@
               </a:rPr>
               <a:t>USER FLOW DEGRADED</a:t>
             </a:r>
+            <a:endParaRPr sz="1000" b="0">
+              <a:solidFill>
+                <a:srgbClr val="E8A850"/>
+              </a:solidFill>
+              <a:latin typeface="JetBrains Mono"/>
+            </a:endParaRPr>
           </a:p>
         </p:txBody>
       </p:sp>
@@ -10780,6 +11460,12 @@
               </a:rPr>
               <a:t>100%</a:t>
             </a:r>
+            <a:endParaRPr sz="3600" b="1">
+              <a:solidFill>
+                <a:srgbClr val="E8A850"/>
+              </a:solidFill>
+              <a:latin typeface="Inter"/>
+            </a:endParaRPr>
           </a:p>
         </p:txBody>
       </p:sp>
@@ -10815,6 +11501,12 @@
               </a:rPr>
               <a:t>Every critical user journey affected by the cascading failure originating at Orders DB.</a:t>
             </a:r>
+            <a:endParaRPr sz="1100" b="0">
+              <a:solidFill>
+                <a:srgbClr val="949CAE"/>
+              </a:solidFill>
+              <a:latin typeface="Inter"/>
+            </a:endParaRPr>
           </a:p>
         </p:txBody>
       </p:sp>
@@ -10850,6 +11542,12 @@
               </a:rPr>
               <a:t>DERIVED FROM SERVICE STATUS</a:t>
             </a:r>
+            <a:endParaRPr sz="800" b="0">
+              <a:solidFill>
+                <a:srgbClr val="5A6070"/>
+              </a:solidFill>
+              <a:latin typeface="JetBrains Mono"/>
+            </a:endParaRPr>
           </a:p>
         </p:txBody>
       </p:sp>
@@ -10977,6 +11675,12 @@
               </a:rPr>
               <a:t>REVENUE AT RISK</a:t>
             </a:r>
+            <a:endParaRPr sz="1000" b="0">
+              <a:solidFill>
+                <a:srgbClr val="F05A6E"/>
+              </a:solidFill>
+              <a:latin typeface="JetBrains Mono"/>
+            </a:endParaRPr>
           </a:p>
         </p:txBody>
       </p:sp>
@@ -11012,6 +11716,12 @@
               </a:rPr>
               <a:t>$34.2k / min</a:t>
             </a:r>
+            <a:endParaRPr sz="3600" b="1">
+              <a:solidFill>
+                <a:srgbClr val="F05A6E"/>
+              </a:solidFill>
+              <a:latin typeface="Inter"/>
+            </a:endParaRPr>
           </a:p>
         </p:txBody>
       </p:sp>
@@ -11047,6 +11757,12 @@
               </a:rPr>
               <a:t>Estimated loss rate at time of incident opening — computed live from service criticality weights.</a:t>
             </a:r>
+            <a:endParaRPr sz="1100" b="0">
+              <a:solidFill>
+                <a:srgbClr val="949CAE"/>
+              </a:solidFill>
+              <a:latin typeface="Inter"/>
+            </a:endParaRPr>
           </a:p>
         </p:txBody>
       </p:sp>
@@ -11082,6 +11798,12 @@
               </a:rPr>
               <a:t>COMPUTED LIVE FROM ENGINE SNAPSHOT</a:t>
             </a:r>
+            <a:endParaRPr sz="800" b="0">
+              <a:solidFill>
+                <a:srgbClr val="5A6070"/>
+              </a:solidFill>
+              <a:latin typeface="JetBrains Mono"/>
+            </a:endParaRPr>
           </a:p>
         </p:txBody>
       </p:sp>
@@ -11094,7 +11816,7 @@
         <p:spPr>
           <a:xfrm>
             <a:off x="548640" y="6080760"/>
-            <a:ext cx="11064240" cy="502920"/>
+            <a:ext cx="10972165" cy="419100"/>
           </a:xfrm>
           <a:prstGeom prst="roundRect">
             <a:avLst>
@@ -11164,49 +11886,12 @@
               </a:rPr>
               <a:t>IMPACT PANEL  ·  SEVERITY: CRITICAL (5+ AFFECTED SERVICES)  ·  COMPUTED FROM snap.metrics  ·  NO HAND-WRITTEN ESTIMATES</a:t>
             </a:r>
-          </a:p>
-        </p:txBody>
-      </p:sp>
-      <p:sp>
-        <p:nvSpPr>
-          <p:cNvPr id="25" name="Rectangle 24"/>
-          <p:cNvSpPr/>
-          <p:nvPr/>
-        </p:nvSpPr>
-        <p:spPr>
-          <a:xfrm>
-            <a:off x="457200" y="6400800"/>
-            <a:ext cx="11247120" cy="6350"/>
-          </a:xfrm>
-          <a:prstGeom prst="rect">
-            <a:avLst/>
-          </a:prstGeom>
-          <a:solidFill>
-            <a:srgbClr val="1A2430"/>
-          </a:solidFill>
-          <a:ln>
-            <a:noFill/>
-          </a:ln>
-        </p:spPr>
-        <p:style>
-          <a:lnRef idx="1">
-            <a:schemeClr val="accent1"/>
-          </a:lnRef>
-          <a:fillRef idx="3">
-            <a:schemeClr val="accent1"/>
-          </a:fillRef>
-          <a:effectRef idx="2">
-            <a:schemeClr val="accent1"/>
-          </a:effectRef>
-          <a:fontRef idx="minor">
-            <a:schemeClr val="lt1"/>
-          </a:fontRef>
-        </p:style>
-        <p:txBody>
-          <a:bodyPr rtlCol="0" anchor="ctr"/>
-          <a:lstStyle/>
-          <a:p>
-            <a:pPr algn="ctr"/>
+            <a:endParaRPr sz="900" b="0">
+              <a:solidFill>
+                <a:srgbClr val="1E6A8C"/>
+              </a:solidFill>
+              <a:latin typeface="JetBrains Mono"/>
+            </a:endParaRPr>
           </a:p>
         </p:txBody>
       </p:sp>
@@ -11218,8 +11903,8 @@
         </p:nvSpPr>
         <p:spPr>
           <a:xfrm>
-            <a:off x="457200" y="6473952"/>
-            <a:ext cx="5943600" cy="274320"/>
+            <a:off x="548640" y="6523482"/>
+            <a:ext cx="5943600" cy="213995"/>
           </a:xfrm>
           <a:prstGeom prst="rect">
             <a:avLst/>
@@ -11240,8 +11925,32 @@
                 </a:solidFill>
                 <a:latin typeface="JetBrains Mono"/>
               </a:rPr>
-              <a:t>ORCATHON 2026  ·  TRACK 01 SOFTWARE &amp; AI  ·  JAY GHEVARIYA (SOLO)</a:t>
-            </a:r>
+              <a:t>ORCATHON 2026  ·  TRACK 01 SOFTWARE &amp; AI  ·  </a:t>
+            </a:r>
+            <a:r>
+              <a:rPr lang="en-IN" sz="800" b="0">
+                <a:solidFill>
+                  <a:srgbClr val="5A6070"/>
+                </a:solidFill>
+                <a:latin typeface="JetBrains Mono"/>
+              </a:rPr>
+              <a:t>PAL</a:t>
+            </a:r>
+            <a:r>
+              <a:rPr sz="800" b="0">
+                <a:solidFill>
+                  <a:srgbClr val="5A6070"/>
+                </a:solidFill>
+                <a:latin typeface="JetBrains Mono"/>
+              </a:rPr>
+              <a:t> GHEVARIYA (SOLO)</a:t>
+            </a:r>
+            <a:endParaRPr sz="800" b="0">
+              <a:solidFill>
+                <a:srgbClr val="5A6070"/>
+              </a:solidFill>
+              <a:latin typeface="JetBrains Mono"/>
+            </a:endParaRPr>
           </a:p>
         </p:txBody>
       </p:sp>
@@ -11253,7 +11962,7 @@
         </p:nvSpPr>
         <p:spPr>
           <a:xfrm>
-            <a:off x="7315200" y="6473952"/>
+            <a:off x="7202170" y="6523482"/>
             <a:ext cx="4114800" cy="274320"/>
           </a:xfrm>
           <a:prstGeom prst="rect">
@@ -11277,6 +11986,12 @@
               </a:rPr>
               <a:t>SCENARIO  ·  POOL-EXHAUSTION  ·  SEVERITY: CRITICAL  ·  AFFECTED SERVICES: 4</a:t>
             </a:r>
+            <a:endParaRPr sz="800" b="0">
+              <a:solidFill>
+                <a:srgbClr val="7A828F"/>
+              </a:solidFill>
+              <a:latin typeface="JetBrains Mono"/>
+            </a:endParaRPr>
           </a:p>
         </p:txBody>
       </p:sp>
@@ -11285,11 +12000,23 @@
   <p:clrMapOvr>
     <a:masterClrMapping/>
   </p:clrMapOvr>
+  <mc:AlternateContent xmlns:mc="http://schemas.openxmlformats.org/markup-compatibility/2006">
+    <mc:Choice xmlns:p15="http://schemas.microsoft.com/office/powerpoint/2012/main" Requires="p15">
+      <p:transition xmlns:p14="http://schemas.microsoft.com/office/powerpoint/2010/main" spd="slow" Requires="p14" p14:dur="1250">
+        <p15:prstTrans prst="airplane"/>
+      </p:transition>
+    </mc:Choice>
+    <mc:Fallback>
+      <p:transition spd="slow">
+        <p:fade/>
+      </p:transition>
+    </mc:Fallback>
+  </mc:AlternateContent>
 </p:sld>
 </file>
 
 <file path=ppt/slides/slide7.xml><?xml version="1.0" encoding="utf-8"?>
-<p:sld xmlns:a="http://schemas.openxmlformats.org/drawingml/2006/main" xmlns:p="http://schemas.openxmlformats.org/presentationml/2006/main" xmlns:r="http://schemas.openxmlformats.org/officeDocument/2006/relationships">
+<p:sld xmlns:a="http://schemas.openxmlformats.org/drawingml/2006/main" xmlns:r="http://schemas.openxmlformats.org/officeDocument/2006/relationships" xmlns:p="http://schemas.openxmlformats.org/presentationml/2006/main">
   <p:cSld>
     <p:bg>
       <p:bgPr>
@@ -11315,7 +12042,7 @@
         <p:spPr>
           <a:xfrm>
             <a:off x="548640" y="365760"/>
-            <a:ext cx="2194560" cy="292608"/>
+            <a:ext cx="2468880" cy="685165"/>
           </a:xfrm>
           <a:prstGeom prst="roundRect">
             <a:avLst>
@@ -11385,6 +12112,12 @@
               </a:rPr>
               <a:t>06  ·  MEASURED BENCHMARKS  ·  REGENERATED BY ENGINE</a:t>
             </a:r>
+            <a:endParaRPr sz="900" b="0">
+              <a:solidFill>
+                <a:srgbClr val="949CAE"/>
+              </a:solidFill>
+              <a:latin typeface="JetBrains Mono"/>
+            </a:endParaRPr>
           </a:p>
         </p:txBody>
       </p:sp>
@@ -11420,6 +12153,12 @@
               </a:rPr>
               <a:t>Every figure below is produced by scripts/evaluate.ts — 4 scenarios, seed 42, 12 sim-min each — and rendered live in the dashboard.</a:t>
             </a:r>
+            <a:endParaRPr sz="1600" b="0">
+              <a:solidFill>
+                <a:srgbClr val="949CAE"/>
+              </a:solidFill>
+              <a:latin typeface="Inter"/>
+            </a:endParaRPr>
           </a:p>
         </p:txBody>
       </p:sp>
@@ -11547,6 +12286,12 @@
               </a:rPr>
               <a:t>75 s</a:t>
             </a:r>
+            <a:endParaRPr sz="3600" b="1">
+              <a:solidFill>
+                <a:srgbClr val="38D0F5"/>
+              </a:solidFill>
+              <a:latin typeface="Inter"/>
+            </a:endParaRPr>
           </a:p>
         </p:txBody>
       </p:sp>
@@ -11582,6 +12327,12 @@
               </a:rPr>
               <a:t>AVERAGE WARNING LEAD TIME</a:t>
             </a:r>
+            <a:endParaRPr sz="900" b="0">
+              <a:solidFill>
+                <a:srgbClr val="38D0F5"/>
+              </a:solidFill>
+              <a:latin typeface="JetBrains Mono"/>
+            </a:endParaRPr>
           </a:p>
         </p:txBody>
       </p:sp>
@@ -11617,6 +12368,12 @@
               </a:rPr>
               <a:t>Up to 120 s in the flagship pool-exhaustion scenario.</a:t>
             </a:r>
+            <a:endParaRPr sz="1000" b="0">
+              <a:solidFill>
+                <a:srgbClr val="949CAE"/>
+              </a:solidFill>
+              <a:latin typeface="Inter"/>
+            </a:endParaRPr>
           </a:p>
         </p:txBody>
       </p:sp>
@@ -11744,6 +12501,12 @@
               </a:rPr>
               <a:t>100%</a:t>
             </a:r>
+            <a:endParaRPr sz="3600" b="1">
+              <a:solidFill>
+                <a:srgbClr val="38D0F5"/>
+              </a:solidFill>
+              <a:latin typeface="Inter"/>
+            </a:endParaRPr>
           </a:p>
         </p:txBody>
       </p:sp>
@@ -11779,6 +12542,12 @@
               </a:rPr>
               <a:t>ORIGIN ACCURACY</a:t>
             </a:r>
+            <a:endParaRPr sz="900" b="0">
+              <a:solidFill>
+                <a:srgbClr val="38D0F5"/>
+              </a:solidFill>
+              <a:latin typeface="JetBrains Mono"/>
+            </a:endParaRPr>
           </a:p>
         </p:txBody>
       </p:sp>
@@ -11814,6 +12583,12 @@
               </a:rPr>
               <a:t>True origin identified correctly across all 4 fault scenarios.</a:t>
             </a:r>
+            <a:endParaRPr sz="1000" b="0">
+              <a:solidFill>
+                <a:srgbClr val="949CAE"/>
+              </a:solidFill>
+              <a:latin typeface="Inter"/>
+            </a:endParaRPr>
           </a:p>
         </p:txBody>
       </p:sp>
@@ -11941,6 +12716,12 @@
               </a:rPr>
               <a:t>100%</a:t>
             </a:r>
+            <a:endParaRPr sz="3600" b="1">
+              <a:solidFill>
+                <a:srgbClr val="38D0F5"/>
+              </a:solidFill>
+              <a:latin typeface="Inter"/>
+            </a:endParaRPr>
           </a:p>
         </p:txBody>
       </p:sp>
@@ -11976,6 +12757,12 @@
               </a:rPr>
               <a:t>RECALL  ·  6 HITS  ·  0 MISSED</a:t>
             </a:r>
+            <a:endParaRPr sz="900" b="0">
+              <a:solidFill>
+                <a:srgbClr val="38D0F5"/>
+              </a:solidFill>
+              <a:latin typeface="JetBrains Mono"/>
+            </a:endParaRPr>
           </a:p>
         </p:txBody>
       </p:sp>
@@ -12011,6 +12798,12 @@
               </a:rPr>
               <a:t>Every failure was predicted before it occurred — no false negatives.</a:t>
             </a:r>
+            <a:endParaRPr sz="1000" b="0">
+              <a:solidFill>
+                <a:srgbClr val="949CAE"/>
+              </a:solidFill>
+              <a:latin typeface="Inter"/>
+            </a:endParaRPr>
           </a:p>
         </p:txBody>
       </p:sp>
@@ -12138,6 +12931,12 @@
               </a:rPr>
               <a:t>75%</a:t>
             </a:r>
+            <a:endParaRPr sz="3600" b="1">
+              <a:solidFill>
+                <a:srgbClr val="38D0F5"/>
+              </a:solidFill>
+              <a:latin typeface="Inter"/>
+            </a:endParaRPr>
           </a:p>
         </p:txBody>
       </p:sp>
@@ -12173,6 +12972,12 @@
               </a:rPr>
               <a:t>PRECISION  ·  HONEST REPORTING</a:t>
             </a:r>
+            <a:endParaRPr sz="900" b="0">
+              <a:solidFill>
+                <a:srgbClr val="38D0F5"/>
+              </a:solidFill>
+              <a:latin typeface="JetBrains Mono"/>
+            </a:endParaRPr>
           </a:p>
         </p:txBody>
       </p:sp>
@@ -12208,6 +13013,12 @@
               </a:rPr>
               <a:t>2 false alarms out of 8 predictions — reported, not smoothed away.</a:t>
             </a:r>
+            <a:endParaRPr sz="1000" b="0">
+              <a:solidFill>
+                <a:srgbClr val="949CAE"/>
+              </a:solidFill>
+              <a:latin typeface="Inter"/>
+            </a:endParaRPr>
           </a:p>
         </p:txBody>
       </p:sp>
@@ -12290,6 +13101,12 @@
               </a:rPr>
               <a:t>POOL-EXHAUSTION  ·  MEMORY-LEAK  ·  TRAFFIC-SURGE  ·  RETRY-STORM</a:t>
             </a:r>
+            <a:endParaRPr sz="1000" b="0">
+              <a:solidFill>
+                <a:srgbClr val="38D0F5"/>
+              </a:solidFill>
+              <a:latin typeface="JetBrains Mono"/>
+            </a:endParaRPr>
           </a:p>
         </p:txBody>
       </p:sp>
@@ -12325,6 +13142,12 @@
               </a:rPr>
               <a:t>AVG LEAD: 75 s  ·  ORIGIN ACC: 100%  ·  PRECISION: 75%  ·  RECALL: 100%  ·  HITS: 6  ·  MISSED: 0</a:t>
             </a:r>
+            <a:endParaRPr sz="900" b="0">
+              <a:solidFill>
+                <a:srgbClr val="F4F6F8"/>
+              </a:solidFill>
+              <a:latin typeface="JetBrains Mono"/>
+            </a:endParaRPr>
           </a:p>
         </p:txBody>
       </p:sp>
@@ -12360,6 +13183,12 @@
               </a:rPr>
               <a:t>SOURCE  ·  docs/evaluation-report.json  ·  public/evaluation-report.json  ·  SEED 42  ·  4 SCENARIOS  ·  12 SIM-MIN EACH</a:t>
             </a:r>
+            <a:endParaRPr sz="800" b="0">
+              <a:solidFill>
+                <a:srgbClr val="5A6070"/>
+              </a:solidFill>
+              <a:latin typeface="JetBrains Mono"/>
+            </a:endParaRPr>
           </a:p>
         </p:txBody>
       </p:sp>
@@ -12415,7 +13244,7 @@
         <p:spPr>
           <a:xfrm>
             <a:off x="457200" y="6473952"/>
-            <a:ext cx="5943600" cy="274320"/>
+            <a:ext cx="5943600" cy="213995"/>
           </a:xfrm>
           <a:prstGeom prst="rect">
             <a:avLst/>
@@ -12436,8 +13265,32 @@
                 </a:solidFill>
                 <a:latin typeface="JetBrains Mono"/>
               </a:rPr>
-              <a:t>ORCATHON 2026  ·  TRACK 01 SOFTWARE &amp; AI  ·  JAY GHEVARIYA (SOLO)</a:t>
-            </a:r>
+              <a:t>ORCATHON 2026  ·  TRACK 01 SOFTWARE &amp; AI  ·  </a:t>
+            </a:r>
+            <a:r>
+              <a:rPr lang="en-IN" sz="800" b="0">
+                <a:solidFill>
+                  <a:srgbClr val="5A6070"/>
+                </a:solidFill>
+                <a:latin typeface="JetBrains Mono"/>
+              </a:rPr>
+              <a:t>Pal</a:t>
+            </a:r>
+            <a:r>
+              <a:rPr sz="800" b="0">
+                <a:solidFill>
+                  <a:srgbClr val="5A6070"/>
+                </a:solidFill>
+                <a:latin typeface="JetBrains Mono"/>
+              </a:rPr>
+              <a:t> GHEVARIYA (SOLO)</a:t>
+            </a:r>
+            <a:endParaRPr sz="800" b="0">
+              <a:solidFill>
+                <a:srgbClr val="5A6070"/>
+              </a:solidFill>
+              <a:latin typeface="JetBrains Mono"/>
+            </a:endParaRPr>
           </a:p>
         </p:txBody>
       </p:sp>
@@ -12473,6 +13326,12 @@
               </a:rPr>
               <a:t>VERIFIED HEADLESS  ·  scripts/evaluate.ts  ·  NO HAND-WRITTEN NUMBERS</a:t>
             </a:r>
+            <a:endParaRPr sz="800" b="0">
+              <a:solidFill>
+                <a:srgbClr val="7A828F"/>
+              </a:solidFill>
+              <a:latin typeface="JetBrains Mono"/>
+            </a:endParaRPr>
           </a:p>
         </p:txBody>
       </p:sp>
@@ -12481,11 +13340,23 @@
   <p:clrMapOvr>
     <a:masterClrMapping/>
   </p:clrMapOvr>
+  <mc:AlternateContent xmlns:mc="http://schemas.openxmlformats.org/markup-compatibility/2006">
+    <mc:Choice xmlns:p15="http://schemas.microsoft.com/office/powerpoint/2012/main" Requires="p15">
+      <p:transition xmlns:p14="http://schemas.microsoft.com/office/powerpoint/2010/main" spd="slow" Requires="p14" p14:dur="1250">
+        <p15:prstTrans prst="airplane"/>
+      </p:transition>
+    </mc:Choice>
+    <mc:Fallback>
+      <p:transition spd="slow">
+        <p:fade/>
+      </p:transition>
+    </mc:Fallback>
+  </mc:AlternateContent>
 </p:sld>
 </file>
 
 <file path=ppt/slides/slide8.xml><?xml version="1.0" encoding="utf-8"?>
-<p:sld xmlns:a="http://schemas.openxmlformats.org/drawingml/2006/main" xmlns:p="http://schemas.openxmlformats.org/presentationml/2006/main" xmlns:r="http://schemas.openxmlformats.org/officeDocument/2006/relationships">
+<p:sld xmlns:a="http://schemas.openxmlformats.org/drawingml/2006/main" xmlns:r="http://schemas.openxmlformats.org/officeDocument/2006/relationships" xmlns:p="http://schemas.openxmlformats.org/presentationml/2006/main">
   <p:cSld>
     <p:bg>
       <p:bgPr>
@@ -12511,7 +13382,7 @@
         <p:spPr>
           <a:xfrm>
             <a:off x="548640" y="365760"/>
-            <a:ext cx="2194560" cy="292608"/>
+            <a:ext cx="2267585" cy="455930"/>
           </a:xfrm>
           <a:prstGeom prst="roundRect">
             <a:avLst>
@@ -12557,8 +13428,49 @@
         </p:nvSpPr>
         <p:spPr>
           <a:xfrm>
-            <a:off x="685800" y="384048"/>
-            <a:ext cx="1920240" cy="256032"/>
+            <a:off x="696595" y="384175"/>
+            <a:ext cx="2119630" cy="438785"/>
+          </a:xfrm>
+          <a:prstGeom prst="rect">
+            <a:avLst/>
+          </a:prstGeom>
+          <a:noFill/>
+        </p:spPr>
+        <p:txBody>
+          <a:bodyPr wrap="square">
+            <a:noAutofit/>
+          </a:bodyPr>
+          <a:lstStyle/>
+          <a:p>
+            <a:pPr algn="ctr"/>
+            <a:r>
+              <a:rPr sz="900" b="0">
+                <a:solidFill>
+                  <a:srgbClr val="949CAE"/>
+                </a:solidFill>
+                <a:latin typeface="JetBrains Mono"/>
+              </a:rPr>
+              <a:t>07  ·  ARCHITECTURE  ·  FULLY CLIENT-SIDE  ·  NO BACKEND</a:t>
+            </a:r>
+            <a:endParaRPr sz="900" b="0">
+              <a:solidFill>
+                <a:srgbClr val="949CAE"/>
+              </a:solidFill>
+              <a:latin typeface="JetBrains Mono"/>
+            </a:endParaRPr>
+          </a:p>
+        </p:txBody>
+      </p:sp>
+      <p:sp>
+        <p:nvSpPr>
+          <p:cNvPr id="4" name="TextBox 3"/>
+          <p:cNvSpPr txBox="1"/>
+          <p:nvPr/>
+        </p:nvSpPr>
+        <p:spPr>
+          <a:xfrm>
+            <a:off x="548640" y="1097280"/>
+            <a:ext cx="10972800" cy="640080"/>
           </a:xfrm>
           <a:prstGeom prst="rect">
             <a:avLst/>
@@ -12571,41 +13483,6 @@
           </a:bodyPr>
           <a:lstStyle/>
           <a:p>
-            <a:pPr algn="ctr"/>
-            <a:r>
-              <a:rPr sz="900" b="0">
-                <a:solidFill>
-                  <a:srgbClr val="949CAE"/>
-                </a:solidFill>
-                <a:latin typeface="JetBrains Mono"/>
-              </a:rPr>
-              <a:t>07  ·  ARCHITECTURE  ·  FULLY CLIENT-SIDE  ·  NO BACKEND</a:t>
-            </a:r>
-          </a:p>
-        </p:txBody>
-      </p:sp>
-      <p:sp>
-        <p:nvSpPr>
-          <p:cNvPr id="4" name="TextBox 3"/>
-          <p:cNvSpPr txBox="1"/>
-          <p:nvPr/>
-        </p:nvSpPr>
-        <p:spPr>
-          <a:xfrm>
-            <a:off x="548640" y="1097280"/>
-            <a:ext cx="10972800" cy="640080"/>
-          </a:xfrm>
-          <a:prstGeom prst="rect">
-            <a:avLst/>
-          </a:prstGeom>
-          <a:noFill/>
-        </p:spPr>
-        <p:txBody>
-          <a:bodyPr wrap="square">
-            <a:spAutoFit/>
-          </a:bodyPr>
-          <a:lstStyle/>
-          <a:p>
             <a:pPr algn="l"/>
             <a:r>
               <a:rPr sz="2800" b="0">
@@ -12616,6 +13493,12 @@
               </a:rPr>
               <a:t>Deterministic twin · Hybrid AI · Verified dashboard</a:t>
             </a:r>
+            <a:endParaRPr sz="2800" b="0">
+              <a:solidFill>
+                <a:srgbClr val="F4F6F8"/>
+              </a:solidFill>
+              <a:latin typeface="Inter"/>
+            </a:endParaRPr>
           </a:p>
         </p:txBody>
       </p:sp>
@@ -12743,6 +13626,12 @@
               </a:rPr>
               <a:t>01</a:t>
             </a:r>
+            <a:endParaRPr sz="1400" b="1">
+              <a:solidFill>
+                <a:srgbClr val="060812"/>
+              </a:solidFill>
+              <a:latin typeface="Inter"/>
+            </a:endParaRPr>
           </a:p>
         </p:txBody>
       </p:sp>
@@ -12778,6 +13667,12 @@
               </a:rPr>
               <a:t>DETERMINISTIC ENGINE</a:t>
             </a:r>
+            <a:endParaRPr sz="1400" b="1">
+              <a:solidFill>
+                <a:srgbClr val="F4F6F8"/>
+              </a:solidFill>
+              <a:latin typeface="Inter"/>
+            </a:endParaRPr>
           </a:p>
         </p:txBody>
       </p:sp>
@@ -12856,6 +13751,12 @@
               </a:rPr>
               <a:t>Seeded mulberry32 PRNG. 9 services · 13 dependency edges · 600 ms real tick = 3000 ms sim step. Telemetry published every simulation step — speed-invariant EWMA trend features.</a:t>
             </a:r>
+            <a:endParaRPr sz="1100" b="0">
+              <a:solidFill>
+                <a:srgbClr val="949CAE"/>
+              </a:solidFill>
+              <a:latin typeface="Inter"/>
+            </a:endParaRPr>
           </a:p>
         </p:txBody>
       </p:sp>
@@ -12983,6 +13884,12 @@
               </a:rPr>
               <a:t>02</a:t>
             </a:r>
+            <a:endParaRPr sz="1400" b="1">
+              <a:solidFill>
+                <a:srgbClr val="060812"/>
+              </a:solidFill>
+              <a:latin typeface="Inter"/>
+            </a:endParaRPr>
           </a:p>
         </p:txBody>
       </p:sp>
@@ -13018,6 +13925,12 @@
               </a:rPr>
               <a:t>HYBRID AI STACK</a:t>
             </a:r>
+            <a:endParaRPr sz="1400" b="1">
+              <a:solidFill>
+                <a:srgbClr val="F4F6F8"/>
+              </a:solidFill>
+              <a:latin typeface="Inter"/>
+            </a:endParaRPr>
           </a:p>
         </p:txBody>
       </p:sp>
@@ -13096,6 +14009,12 @@
               </a:rPr>
               <a:t>Logistic risk scorer (EWMA + slope features) · 2-hop graph propagation · self-vs-dependency-explained root-cause scoring · paired Monte-Carlo recovery (30 rollouts / 7 strategies).</a:t>
             </a:r>
+            <a:endParaRPr sz="1100" b="0">
+              <a:solidFill>
+                <a:srgbClr val="949CAE"/>
+              </a:solidFill>
+              <a:latin typeface="Inter"/>
+            </a:endParaRPr>
           </a:p>
         </p:txBody>
       </p:sp>
@@ -13223,6 +14142,12 @@
               </a:rPr>
               <a:t>03</a:t>
             </a:r>
+            <a:endParaRPr sz="1400" b="1">
+              <a:solidFill>
+                <a:srgbClr val="060812"/>
+              </a:solidFill>
+              <a:latin typeface="Inter"/>
+            </a:endParaRPr>
           </a:p>
         </p:txBody>
       </p:sp>
@@ -13258,6 +14183,12 @@
               </a:rPr>
               <a:t>VERIFIED DASHBOARD</a:t>
             </a:r>
+            <a:endParaRPr sz="1400" b="1">
+              <a:solidFill>
+                <a:srgbClr val="F4F6F8"/>
+              </a:solidFill>
+              <a:latin typeface="Inter"/>
+            </a:endParaRPr>
           </a:p>
         </p:txBody>
       </p:sp>
@@ -13336,6 +14267,12 @@
               </a:rPr>
               <a:t>Prediction Ledger (✓ HIT / false-alarm / missed) · Service Deep-Dive drawer (metrics + trends + dependency graph) · Measured Benchmarks · Markdown incident report · keyboard shortcuts.</a:t>
             </a:r>
+            <a:endParaRPr sz="1100" b="0">
+              <a:solidFill>
+                <a:srgbClr val="949CAE"/>
+              </a:solidFill>
+              <a:latin typeface="Inter"/>
+            </a:endParaRPr>
           </a:p>
         </p:txBody>
       </p:sp>
@@ -13395,7 +14332,7 @@
         <p:spPr>
           <a:xfrm>
             <a:off x="731520" y="5394960"/>
-            <a:ext cx="10515600" cy="548640"/>
+            <a:ext cx="10515600" cy="521970"/>
           </a:xfrm>
           <a:prstGeom prst="rect">
             <a:avLst/>
@@ -13416,8 +14353,32 @@
                 </a:solidFill>
                 <a:latin typeface="Inter"/>
               </a:rPr>
-              <a:t>Predict · Trace · Recover  ·  Fully open source  ·  Live: cascadeguard-ten.vercel.app  ·  GitHub: pal-123456789/cascadeguard  ·  Built for Orcathon 2026 · Jay Ghevariya (solo)</a:t>
-            </a:r>
+              <a:t>Predict · Trace · Recover  ·  Fully open source  ·  Live: cascadeguard-ten.vercel.app  ·  GitHub: pal-123456789/cascadeguard  ·  Built for Orcathon 2026 · </a:t>
+            </a:r>
+            <a:r>
+              <a:rPr lang="en-IN" sz="1400" b="0">
+                <a:solidFill>
+                  <a:srgbClr val="F4F6F8"/>
+                </a:solidFill>
+                <a:latin typeface="Inter"/>
+              </a:rPr>
+              <a:t>Pal</a:t>
+            </a:r>
+            <a:r>
+              <a:rPr sz="1400" b="0">
+                <a:solidFill>
+                  <a:srgbClr val="F4F6F8"/>
+                </a:solidFill>
+                <a:latin typeface="Inter"/>
+              </a:rPr>
+              <a:t> Ghevariya (solo)</a:t>
+            </a:r>
+            <a:endParaRPr sz="1400" b="0">
+              <a:solidFill>
+                <a:srgbClr val="F4F6F8"/>
+              </a:solidFill>
+              <a:latin typeface="Inter"/>
+            </a:endParaRPr>
           </a:p>
         </p:txBody>
       </p:sp>
@@ -13453,6 +14414,12 @@
               </a:rPr>
               <a:t>Every claim verified by the engine's own ground truth · Every number regenerated by scripts/evaluate.ts · No black-box AI · No hand-written estimates</a:t>
             </a:r>
+            <a:endParaRPr sz="1000" b="0">
+              <a:solidFill>
+                <a:srgbClr val="1E6A8C"/>
+              </a:solidFill>
+              <a:latin typeface="JetBrains Mono"/>
+            </a:endParaRPr>
           </a:p>
         </p:txBody>
       </p:sp>
@@ -13508,7 +14475,7 @@
         <p:spPr>
           <a:xfrm>
             <a:off x="457200" y="6473952"/>
-            <a:ext cx="5943600" cy="274320"/>
+            <a:ext cx="5943600" cy="213995"/>
           </a:xfrm>
           <a:prstGeom prst="rect">
             <a:avLst/>
@@ -13529,8 +14496,32 @@
                 </a:solidFill>
                 <a:latin typeface="JetBrains Mono"/>
               </a:rPr>
-              <a:t>ORCATHON 2026  ·  TRACK 01 SOFTWARE &amp; AI  ·  JAY GHEVARIYA (SOLO)</a:t>
-            </a:r>
+              <a:t>ORCATHON 2026  ·  TRACK 01 SOFTWARE &amp; AI  ·  </a:t>
+            </a:r>
+            <a:r>
+              <a:rPr lang="en-IN" sz="800" b="0">
+                <a:solidFill>
+                  <a:srgbClr val="5A6070"/>
+                </a:solidFill>
+                <a:latin typeface="JetBrains Mono"/>
+              </a:rPr>
+              <a:t>PAL</a:t>
+            </a:r>
+            <a:r>
+              <a:rPr sz="800" b="0">
+                <a:solidFill>
+                  <a:srgbClr val="5A6070"/>
+                </a:solidFill>
+                <a:latin typeface="JetBrains Mono"/>
+              </a:rPr>
+              <a:t> GHEVARIYA (SOLO)</a:t>
+            </a:r>
+            <a:endParaRPr sz="800" b="0">
+              <a:solidFill>
+                <a:srgbClr val="5A6070"/>
+              </a:solidFill>
+              <a:latin typeface="JetBrains Mono"/>
+            </a:endParaRPr>
           </a:p>
         </p:txBody>
       </p:sp>
@@ -13566,6 +14557,12 @@
               </a:rPr>
               <a:t>TYPECHECK: CLEAN  ·  SMOKE: ALL PASS  ·  BUILD: 436 ms  ·  DEPLOY: VERCEL  ·  VIDEO: 3-MIN DEMO READY</a:t>
             </a:r>
+            <a:endParaRPr sz="800" b="0">
+              <a:solidFill>
+                <a:srgbClr val="7A828F"/>
+              </a:solidFill>
+              <a:latin typeface="JetBrains Mono"/>
+            </a:endParaRPr>
           </a:p>
         </p:txBody>
       </p:sp>
@@ -13574,6 +14571,18 @@
   <p:clrMapOvr>
     <a:masterClrMapping/>
   </p:clrMapOvr>
+  <mc:AlternateContent xmlns:mc="http://schemas.openxmlformats.org/markup-compatibility/2006">
+    <mc:Choice xmlns:p15="http://schemas.microsoft.com/office/powerpoint/2012/main" Requires="p15">
+      <p:transition xmlns:p14="http://schemas.microsoft.com/office/powerpoint/2010/main" spd="slow" Requires="p14" p14:dur="1250">
+        <p15:prstTrans prst="airplane"/>
+      </p:transition>
+    </mc:Choice>
+    <mc:Fallback>
+      <p:transition spd="slow">
+        <p:fade/>
+      </p:transition>
+    </mc:Fallback>
+  </mc:AlternateContent>
 </p:sld>
 </file>
 
@@ -13893,6 +14902,10 @@
       </a:style>
     </a:lnDef>
   </a:objectDefaults>
-  <a:extraClrSchemeLst/>
+  <a:extLst>
+    <a:ext uri="{05A4C25C-085E-4340-85A3-A5531E510DB2}">
+      <thm15:themeFamily xmlns:thm15="http://schemas.microsoft.com/office/thememl/2012/main" name="Office Theme" id="{62F939B6-93AF-4DB8-9C6B-D6C7DFDC589F}" vid="{4A3C46E8-61CC-4603-A589-7422A47A8E4A}"/>
+    </a:ext>
+  </a:extLst>
 </a:theme>
 </file>
</xml_diff>